<commit_message>
Power Point Bemutató frissítve
</commit_message>
<xml_diff>
--- a/etelfutar_ppt_uj.pptx
+++ b/etelfutar_ppt_uj.pptx
@@ -19,6 +19,8 @@
     <p:sldId id="264" r:id="rId14"/>
     <p:sldId id="265" r:id="rId15"/>
     <p:sldId id="266" r:id="rId16"/>
+    <p:sldId id="267" r:id="rId17"/>
+    <p:sldId id="268" r:id="rId18"/>
   </p:sldIdLst>
   <p:sldSz cy="5143500" cx="9144000"/>
   <p:notesSz cx="6858000" cy="9144000"/>
@@ -967,7 +969,7 @@
       </p:grpSpPr>
       <p:sp>
         <p:nvSpPr>
-          <p:cNvPr id="106" name="Google Shape;106;p9:notes"/>
+          <p:cNvPr id="106" name="Google Shape;106;p10:notes"/>
           <p:cNvSpPr/>
           <p:nvPr>
             <p:ph idx="2" type="sldImg"/>
@@ -1012,7 +1014,7 @@
       </p:sp>
       <p:sp>
         <p:nvSpPr>
-          <p:cNvPr id="107" name="Google Shape;107;p9:notes"/>
+          <p:cNvPr id="107" name="Google Shape;107;p10:notes"/>
           <p:cNvSpPr txBox="1"/>
           <p:nvPr>
             <p:ph idx="1" type="body"/>
@@ -1084,7 +1086,7 @@
       </p:grpSpPr>
       <p:sp>
         <p:nvSpPr>
-          <p:cNvPr id="112" name="Google Shape;112;p10:notes"/>
+          <p:cNvPr id="112" name="Google Shape;112;p11:notes"/>
           <p:cNvSpPr/>
           <p:nvPr>
             <p:ph idx="2" type="sldImg"/>
@@ -1129,7 +1131,241 @@
       </p:sp>
       <p:sp>
         <p:nvSpPr>
-          <p:cNvPr id="113" name="Google Shape;113;p10:notes"/>
+          <p:cNvPr id="113" name="Google Shape;113;p11:notes"/>
+          <p:cNvSpPr txBox="1"/>
+          <p:nvPr>
+            <p:ph idx="1" type="body"/>
+          </p:nvPr>
+        </p:nvSpPr>
+        <p:spPr>
+          <a:xfrm>
+            <a:off x="685800" y="4343400"/>
+            <a:ext cx="5486400" cy="4114800"/>
+          </a:xfrm>
+          <a:prstGeom prst="rect">
+            <a:avLst/>
+          </a:prstGeom>
+          <a:noFill/>
+          <a:ln>
+            <a:noFill/>
+          </a:ln>
+        </p:spPr>
+        <p:txBody>
+          <a:bodyPr anchorCtr="0" anchor="t" bIns="91425" lIns="91425" spcFirstLastPara="1" rIns="91425" wrap="square" tIns="91425">
+            <a:noAutofit/>
+          </a:bodyPr>
+          <a:lstStyle/>
+          <a:p>
+            <a:pPr indent="0" lvl="0" marL="0" rtl="0" algn="l">
+              <a:lnSpc>
+                <a:spcPct val="100000"/>
+              </a:lnSpc>
+              <a:spcBef>
+                <a:spcPts val="0"/>
+              </a:spcBef>
+              <a:spcAft>
+                <a:spcPts val="0"/>
+              </a:spcAft>
+              <a:buSzPts val="1100"/>
+              <a:buNone/>
+            </a:pPr>
+            <a:r>
+              <a:t/>
+            </a:r>
+            <a:endParaRPr/>
+          </a:p>
+        </p:txBody>
+      </p:sp>
+    </p:spTree>
+  </p:cSld>
+  <p:clrMapOvr>
+    <a:masterClrMapping/>
+  </p:clrMapOvr>
+</p:notes>
+</file>
+
+<file path=ppt/notesSlides/notesSlide12.xml><?xml version="1.0" encoding="utf-8"?>
+<p:notes xmlns:a="http://schemas.openxmlformats.org/drawingml/2006/main" xmlns:r="http://schemas.openxmlformats.org/officeDocument/2006/relationships" xmlns:mc="http://schemas.openxmlformats.org/markup-compatibility/2006" xmlns:mv="urn:schemas-microsoft-com:mac:vml" xmlns:p="http://schemas.openxmlformats.org/presentationml/2006/main" xmlns:c="http://schemas.openxmlformats.org/drawingml/2006/chart" xmlns:dgm="http://schemas.openxmlformats.org/drawingml/2006/diagram" xmlns:o="urn:schemas-microsoft-com:office:office" xmlns:v="urn:schemas-microsoft-com:vml" xmlns:pvml="urn:schemas-microsoft-com:office:powerpoint" xmlns:com="http://schemas.openxmlformats.org/drawingml/2006/compatibility" xmlns:p14="http://schemas.microsoft.com/office/powerpoint/2010/main" xmlns:p15="http://schemas.microsoft.com/office/powerpoint/2012/main" xmlns:ahyp="http://schemas.microsoft.com/office/drawing/2018/hyperlinkcolor" showMasterPhAnim="0" showMasterSp="0">
+  <p:cSld>
+    <p:spTree>
+      <p:nvGrpSpPr>
+        <p:cNvPr id="117" name="Shape 117"/>
+        <p:cNvGrpSpPr/>
+        <p:nvPr/>
+      </p:nvGrpSpPr>
+      <p:grpSpPr>
+        <a:xfrm>
+          <a:off x="0" y="0"/>
+          <a:ext cx="0" cy="0"/>
+          <a:chOff x="0" y="0"/>
+          <a:chExt cx="0" cy="0"/>
+        </a:xfrm>
+      </p:grpSpPr>
+      <p:sp>
+        <p:nvSpPr>
+          <p:cNvPr id="118" name="Google Shape;118;g32fcb92857c_0_0:notes"/>
+          <p:cNvSpPr/>
+          <p:nvPr>
+            <p:ph idx="2" type="sldImg"/>
+          </p:nvPr>
+        </p:nvSpPr>
+        <p:spPr>
+          <a:xfrm>
+            <a:off x="381300" y="685800"/>
+            <a:ext cx="6096000" cy="3429000"/>
+          </a:xfrm>
+          <a:custGeom>
+            <a:rect b="b" l="l" r="r" t="t"/>
+            <a:pathLst>
+              <a:path extrusionOk="0" h="120000" w="120000">
+                <a:moveTo>
+                  <a:pt x="0" y="0"/>
+                </a:moveTo>
+                <a:lnTo>
+                  <a:pt x="120000" y="0"/>
+                </a:lnTo>
+                <a:lnTo>
+                  <a:pt x="120000" y="120000"/>
+                </a:lnTo>
+                <a:lnTo>
+                  <a:pt x="0" y="120000"/>
+                </a:lnTo>
+                <a:close/>
+              </a:path>
+            </a:pathLst>
+          </a:custGeom>
+          <a:noFill/>
+          <a:ln cap="flat" cmpd="sng" w="9525">
+            <a:solidFill>
+              <a:srgbClr val="000000"/>
+            </a:solidFill>
+            <a:prstDash val="solid"/>
+            <a:round/>
+            <a:headEnd len="sm" w="sm" type="none"/>
+            <a:tailEnd len="sm" w="sm" type="none"/>
+          </a:ln>
+        </p:spPr>
+      </p:sp>
+      <p:sp>
+        <p:nvSpPr>
+          <p:cNvPr id="119" name="Google Shape;119;g32fcb92857c_0_0:notes"/>
+          <p:cNvSpPr txBox="1"/>
+          <p:nvPr>
+            <p:ph idx="1" type="body"/>
+          </p:nvPr>
+        </p:nvSpPr>
+        <p:spPr>
+          <a:xfrm>
+            <a:off x="685800" y="4343400"/>
+            <a:ext cx="5486400" cy="4114800"/>
+          </a:xfrm>
+          <a:prstGeom prst="rect">
+            <a:avLst/>
+          </a:prstGeom>
+          <a:noFill/>
+          <a:ln>
+            <a:noFill/>
+          </a:ln>
+        </p:spPr>
+        <p:txBody>
+          <a:bodyPr anchorCtr="0" anchor="t" bIns="91425" lIns="91425" spcFirstLastPara="1" rIns="91425" wrap="square" tIns="91425">
+            <a:noAutofit/>
+          </a:bodyPr>
+          <a:lstStyle/>
+          <a:p>
+            <a:pPr indent="0" lvl="0" marL="0" rtl="0" algn="l">
+              <a:lnSpc>
+                <a:spcPct val="100000"/>
+              </a:lnSpc>
+              <a:spcBef>
+                <a:spcPts val="0"/>
+              </a:spcBef>
+              <a:spcAft>
+                <a:spcPts val="0"/>
+              </a:spcAft>
+              <a:buSzPts val="1100"/>
+              <a:buNone/>
+            </a:pPr>
+            <a:r>
+              <a:t/>
+            </a:r>
+            <a:endParaRPr/>
+          </a:p>
+        </p:txBody>
+      </p:sp>
+    </p:spTree>
+  </p:cSld>
+  <p:clrMapOvr>
+    <a:masterClrMapping/>
+  </p:clrMapOvr>
+</p:notes>
+</file>
+
+<file path=ppt/notesSlides/notesSlide13.xml><?xml version="1.0" encoding="utf-8"?>
+<p:notes xmlns:a="http://schemas.openxmlformats.org/drawingml/2006/main" xmlns:r="http://schemas.openxmlformats.org/officeDocument/2006/relationships" xmlns:mc="http://schemas.openxmlformats.org/markup-compatibility/2006" xmlns:mv="urn:schemas-microsoft-com:mac:vml" xmlns:p="http://schemas.openxmlformats.org/presentationml/2006/main" xmlns:c="http://schemas.openxmlformats.org/drawingml/2006/chart" xmlns:dgm="http://schemas.openxmlformats.org/drawingml/2006/diagram" xmlns:o="urn:schemas-microsoft-com:office:office" xmlns:v="urn:schemas-microsoft-com:vml" xmlns:pvml="urn:schemas-microsoft-com:office:powerpoint" xmlns:com="http://schemas.openxmlformats.org/drawingml/2006/compatibility" xmlns:p14="http://schemas.microsoft.com/office/powerpoint/2010/main" xmlns:p15="http://schemas.microsoft.com/office/powerpoint/2012/main" xmlns:ahyp="http://schemas.microsoft.com/office/drawing/2018/hyperlinkcolor" showMasterPhAnim="0" showMasterSp="0">
+  <p:cSld>
+    <p:spTree>
+      <p:nvGrpSpPr>
+        <p:cNvPr id="123" name="Shape 123"/>
+        <p:cNvGrpSpPr/>
+        <p:nvPr/>
+      </p:nvGrpSpPr>
+      <p:grpSpPr>
+        <a:xfrm>
+          <a:off x="0" y="0"/>
+          <a:ext cx="0" cy="0"/>
+          <a:chOff x="0" y="0"/>
+          <a:chExt cx="0" cy="0"/>
+        </a:xfrm>
+      </p:grpSpPr>
+      <p:sp>
+        <p:nvSpPr>
+          <p:cNvPr id="124" name="Google Shape;124;g32fcb92857c_0_8:notes"/>
+          <p:cNvSpPr/>
+          <p:nvPr>
+            <p:ph idx="2" type="sldImg"/>
+          </p:nvPr>
+        </p:nvSpPr>
+        <p:spPr>
+          <a:xfrm>
+            <a:off x="381300" y="685800"/>
+            <a:ext cx="6096000" cy="3429000"/>
+          </a:xfrm>
+          <a:custGeom>
+            <a:rect b="b" l="l" r="r" t="t"/>
+            <a:pathLst>
+              <a:path extrusionOk="0" h="120000" w="120000">
+                <a:moveTo>
+                  <a:pt x="0" y="0"/>
+                </a:moveTo>
+                <a:lnTo>
+                  <a:pt x="120000" y="0"/>
+                </a:lnTo>
+                <a:lnTo>
+                  <a:pt x="120000" y="120000"/>
+                </a:lnTo>
+                <a:lnTo>
+                  <a:pt x="0" y="120000"/>
+                </a:lnTo>
+                <a:close/>
+              </a:path>
+            </a:pathLst>
+          </a:custGeom>
+          <a:noFill/>
+          <a:ln cap="flat" cmpd="sng" w="9525">
+            <a:solidFill>
+              <a:srgbClr val="000000"/>
+            </a:solidFill>
+            <a:prstDash val="solid"/>
+            <a:round/>
+            <a:headEnd len="sm" w="sm" type="none"/>
+            <a:tailEnd len="sm" w="sm" type="none"/>
+          </a:ln>
+        </p:spPr>
+      </p:sp>
+      <p:sp>
+        <p:nvSpPr>
+          <p:cNvPr id="125" name="Google Shape;125;g32fcb92857c_0_8:notes"/>
           <p:cNvSpPr txBox="1"/>
           <p:nvPr>
             <p:ph idx="1" type="body"/>
@@ -1552,7 +1788,7 @@
       </p:grpSpPr>
       <p:sp>
         <p:nvSpPr>
-          <p:cNvPr id="75" name="Google Shape;75;g32db9b2667c_0_0:notes"/>
+          <p:cNvPr id="75" name="Google Shape;75;p5:notes"/>
           <p:cNvSpPr/>
           <p:nvPr>
             <p:ph idx="2" type="sldImg"/>
@@ -1597,7 +1833,7 @@
       </p:sp>
       <p:sp>
         <p:nvSpPr>
-          <p:cNvPr id="76" name="Google Shape;76;g32db9b2667c_0_0:notes"/>
+          <p:cNvPr id="76" name="Google Shape;76;p5:notes"/>
           <p:cNvSpPr txBox="1"/>
           <p:nvPr>
             <p:ph idx="1" type="body"/>
@@ -1669,7 +1905,7 @@
       </p:grpSpPr>
       <p:sp>
         <p:nvSpPr>
-          <p:cNvPr id="82" name="Google Shape;82;p5:notes"/>
+          <p:cNvPr id="82" name="Google Shape;82;p6:notes"/>
           <p:cNvSpPr/>
           <p:nvPr>
             <p:ph idx="2" type="sldImg"/>
@@ -1714,7 +1950,7 @@
       </p:sp>
       <p:sp>
         <p:nvSpPr>
-          <p:cNvPr id="83" name="Google Shape;83;p5:notes"/>
+          <p:cNvPr id="83" name="Google Shape;83;p6:notes"/>
           <p:cNvSpPr txBox="1"/>
           <p:nvPr>
             <p:ph idx="1" type="body"/>
@@ -1786,7 +2022,7 @@
       </p:grpSpPr>
       <p:sp>
         <p:nvSpPr>
-          <p:cNvPr id="88" name="Google Shape;88;p6:notes"/>
+          <p:cNvPr id="88" name="Google Shape;88;p7:notes"/>
           <p:cNvSpPr/>
           <p:nvPr>
             <p:ph idx="2" type="sldImg"/>
@@ -1831,7 +2067,7 @@
       </p:sp>
       <p:sp>
         <p:nvSpPr>
-          <p:cNvPr id="89" name="Google Shape;89;p6:notes"/>
+          <p:cNvPr id="89" name="Google Shape;89;p7:notes"/>
           <p:cNvSpPr txBox="1"/>
           <p:nvPr>
             <p:ph idx="1" type="body"/>
@@ -1903,7 +2139,7 @@
       </p:grpSpPr>
       <p:sp>
         <p:nvSpPr>
-          <p:cNvPr id="94" name="Google Shape;94;p7:notes"/>
+          <p:cNvPr id="94" name="Google Shape;94;p8:notes"/>
           <p:cNvSpPr/>
           <p:nvPr>
             <p:ph idx="2" type="sldImg"/>
@@ -1948,7 +2184,7 @@
       </p:sp>
       <p:sp>
         <p:nvSpPr>
-          <p:cNvPr id="95" name="Google Shape;95;p7:notes"/>
+          <p:cNvPr id="95" name="Google Shape;95;p8:notes"/>
           <p:cNvSpPr txBox="1"/>
           <p:nvPr>
             <p:ph idx="1" type="body"/>
@@ -2020,7 +2256,7 @@
       </p:grpSpPr>
       <p:sp>
         <p:nvSpPr>
-          <p:cNvPr id="100" name="Google Shape;100;p8:notes"/>
+          <p:cNvPr id="100" name="Google Shape;100;p9:notes"/>
           <p:cNvSpPr/>
           <p:nvPr>
             <p:ph idx="2" type="sldImg"/>
@@ -2065,7 +2301,7 @@
       </p:sp>
       <p:sp>
         <p:nvSpPr>
-          <p:cNvPr id="101" name="Google Shape;101;p8:notes"/>
+          <p:cNvPr id="101" name="Google Shape;101;p9:notes"/>
           <p:cNvSpPr txBox="1"/>
           <p:nvPr>
             <p:ph idx="1" type="body"/>
@@ -9868,7 +10104,7 @@
               <a:spcAft>
                 <a:spcPts val="0"/>
               </a:spcAft>
-              <a:buSzPct val="117647"/>
+              <a:buSzPct val="117646"/>
               <a:buNone/>
             </a:pPr>
             <a:r>
@@ -10062,17 +10298,322 @@
           <p:cNvPicPr preferRelativeResize="0"/>
           <p:nvPr/>
         </p:nvPicPr>
-        <p:blipFill rotWithShape="1">
+        <p:blipFill>
           <a:blip r:embed="rId3">
             <a:alphaModFix/>
           </a:blip>
-          <a:srcRect b="0" l="0" r="0" t="0"/>
-          <a:stretch/>
+          <a:stretch>
+            <a:fillRect/>
+          </a:stretch>
         </p:blipFill>
         <p:spPr>
           <a:xfrm>
             <a:off x="152400" y="1170125"/>
-            <a:ext cx="8088504" cy="3820976"/>
+            <a:ext cx="8079595" cy="3820975"/>
+          </a:xfrm>
+          <a:prstGeom prst="rect">
+            <a:avLst/>
+          </a:prstGeom>
+          <a:noFill/>
+          <a:ln>
+            <a:noFill/>
+          </a:ln>
+        </p:spPr>
+      </p:pic>
+    </p:spTree>
+  </p:cSld>
+  <p:clrMapOvr>
+    <a:masterClrMapping/>
+  </p:clrMapOvr>
+</p:sld>
+</file>
+
+<file path=ppt/slides/slide12.xml><?xml version="1.0" encoding="utf-8"?>
+<p:sld xmlns:a="http://schemas.openxmlformats.org/drawingml/2006/main" xmlns:r="http://schemas.openxmlformats.org/officeDocument/2006/relationships" xmlns:mc="http://schemas.openxmlformats.org/markup-compatibility/2006" xmlns:mv="urn:schemas-microsoft-com:mac:vml" xmlns:p="http://schemas.openxmlformats.org/presentationml/2006/main" xmlns:c="http://schemas.openxmlformats.org/drawingml/2006/chart" xmlns:dgm="http://schemas.openxmlformats.org/drawingml/2006/diagram" xmlns:o="urn:schemas-microsoft-com:office:office" xmlns:v="urn:schemas-microsoft-com:vml" xmlns:pvml="urn:schemas-microsoft-com:office:powerpoint" xmlns:com="http://schemas.openxmlformats.org/drawingml/2006/compatibility" xmlns:p14="http://schemas.microsoft.com/office/powerpoint/2010/main" xmlns:p15="http://schemas.microsoft.com/office/powerpoint/2012/main" xmlns:ahyp="http://schemas.microsoft.com/office/drawing/2018/hyperlinkcolor">
+  <p:cSld>
+    <p:spTree>
+      <p:nvGrpSpPr>
+        <p:cNvPr id="120" name="Shape 120"/>
+        <p:cNvGrpSpPr/>
+        <p:nvPr/>
+      </p:nvGrpSpPr>
+      <p:grpSpPr>
+        <a:xfrm>
+          <a:off x="0" y="0"/>
+          <a:ext cx="0" cy="0"/>
+          <a:chOff x="0" y="0"/>
+          <a:chExt cx="0" cy="0"/>
+        </a:xfrm>
+      </p:grpSpPr>
+      <p:sp>
+        <p:nvSpPr>
+          <p:cNvPr id="121" name="Google Shape;121;p24"/>
+          <p:cNvSpPr txBox="1"/>
+          <p:nvPr>
+            <p:ph type="title"/>
+          </p:nvPr>
+        </p:nvSpPr>
+        <p:spPr>
+          <a:xfrm>
+            <a:off x="311700" y="445025"/>
+            <a:ext cx="8520600" cy="572700"/>
+          </a:xfrm>
+          <a:prstGeom prst="rect">
+            <a:avLst/>
+          </a:prstGeom>
+          <a:noFill/>
+          <a:ln>
+            <a:noFill/>
+          </a:ln>
+        </p:spPr>
+        <p:txBody>
+          <a:bodyPr anchorCtr="0" anchor="t" bIns="91425" lIns="91425" spcFirstLastPara="1" rIns="91425" wrap="square" tIns="91425">
+            <a:normAutofit fontScale="90000"/>
+          </a:bodyPr>
+          <a:lstStyle/>
+          <a:p>
+            <a:pPr indent="0" lvl="0" marL="0" rtl="0" algn="l">
+              <a:lnSpc>
+                <a:spcPct val="100000"/>
+              </a:lnSpc>
+              <a:spcBef>
+                <a:spcPts val="0"/>
+              </a:spcBef>
+              <a:spcAft>
+                <a:spcPts val="0"/>
+              </a:spcAft>
+              <a:buSzPct val="111111"/>
+              <a:buNone/>
+            </a:pPr>
+            <a:r>
+              <a:rPr lang="hu"/>
+              <a:t>Adminisztrációs felület-WPF Alkalmazás:</a:t>
+            </a:r>
+            <a:endParaRPr/>
+          </a:p>
+        </p:txBody>
+      </p:sp>
+      <p:sp>
+        <p:nvSpPr>
+          <p:cNvPr id="122" name="Google Shape;122;p24"/>
+          <p:cNvSpPr txBox="1"/>
+          <p:nvPr/>
+        </p:nvSpPr>
+        <p:spPr>
+          <a:xfrm>
+            <a:off x="311700" y="1017725"/>
+            <a:ext cx="8335500" cy="1723800"/>
+          </a:xfrm>
+          <a:prstGeom prst="rect">
+            <a:avLst/>
+          </a:prstGeom>
+          <a:noFill/>
+          <a:ln>
+            <a:noFill/>
+          </a:ln>
+        </p:spPr>
+        <p:txBody>
+          <a:bodyPr anchorCtr="0" anchor="t" bIns="91425" lIns="91425" spcFirstLastPara="1" rIns="91425" wrap="square" tIns="91425">
+            <a:spAutoFit/>
+          </a:bodyPr>
+          <a:lstStyle/>
+          <a:p>
+            <a:pPr indent="0" lvl="0" marL="0" rtl="0" algn="l">
+              <a:spcBef>
+                <a:spcPts val="0"/>
+              </a:spcBef>
+              <a:spcAft>
+                <a:spcPts val="0"/>
+              </a:spcAft>
+              <a:buNone/>
+            </a:pPr>
+            <a:r>
+              <a:rPr lang="hu" sz="2000">
+                <a:solidFill>
+                  <a:schemeClr val="dk1"/>
+                </a:solidFill>
+              </a:rPr>
+              <a:t>A WPF alkalmazás egy felhasználó kezelő program amely segítségével az “Adminisztrátor” kezelheti a felhasználóit: létrehozhat újat,törölhet,módosíthat.</a:t>
+            </a:r>
+            <a:endParaRPr sz="2000">
+              <a:solidFill>
+                <a:schemeClr val="dk1"/>
+              </a:solidFill>
+            </a:endParaRPr>
+          </a:p>
+          <a:p>
+            <a:pPr indent="0" lvl="0" marL="0" rtl="0" algn="l">
+              <a:spcBef>
+                <a:spcPts val="0"/>
+              </a:spcBef>
+              <a:spcAft>
+                <a:spcPts val="0"/>
+              </a:spcAft>
+              <a:buNone/>
+            </a:pPr>
+            <a:r>
+              <a:rPr lang="hu" sz="2000">
+                <a:solidFill>
+                  <a:schemeClr val="dk1"/>
+                </a:solidFill>
+              </a:rPr>
+              <a:t>Csak be kell jelentkezni “Admin” felhasználóként és kész. Illetve be is lehet regisztrálni egy új felhasználót.</a:t>
+            </a:r>
+            <a:endParaRPr sz="2000">
+              <a:solidFill>
+                <a:schemeClr val="dk1"/>
+              </a:solidFill>
+            </a:endParaRPr>
+          </a:p>
+        </p:txBody>
+      </p:sp>
+    </p:spTree>
+  </p:cSld>
+  <p:clrMapOvr>
+    <a:masterClrMapping/>
+  </p:clrMapOvr>
+</p:sld>
+</file>
+
+<file path=ppt/slides/slide13.xml><?xml version="1.0" encoding="utf-8"?>
+<p:sld xmlns:a="http://schemas.openxmlformats.org/drawingml/2006/main" xmlns:r="http://schemas.openxmlformats.org/officeDocument/2006/relationships" xmlns:mc="http://schemas.openxmlformats.org/markup-compatibility/2006" xmlns:mv="urn:schemas-microsoft-com:mac:vml" xmlns:p="http://schemas.openxmlformats.org/presentationml/2006/main" xmlns:c="http://schemas.openxmlformats.org/drawingml/2006/chart" xmlns:dgm="http://schemas.openxmlformats.org/drawingml/2006/diagram" xmlns:o="urn:schemas-microsoft-com:office:office" xmlns:v="urn:schemas-microsoft-com:vml" xmlns:pvml="urn:schemas-microsoft-com:office:powerpoint" xmlns:com="http://schemas.openxmlformats.org/drawingml/2006/compatibility" xmlns:p14="http://schemas.microsoft.com/office/powerpoint/2010/main" xmlns:p15="http://schemas.microsoft.com/office/powerpoint/2012/main" xmlns:ahyp="http://schemas.microsoft.com/office/drawing/2018/hyperlinkcolor">
+  <p:cSld>
+    <p:spTree>
+      <p:nvGrpSpPr>
+        <p:cNvPr id="126" name="Shape 126"/>
+        <p:cNvGrpSpPr/>
+        <p:nvPr/>
+      </p:nvGrpSpPr>
+      <p:grpSpPr>
+        <a:xfrm>
+          <a:off x="0" y="0"/>
+          <a:ext cx="0" cy="0"/>
+          <a:chOff x="0" y="0"/>
+          <a:chExt cx="0" cy="0"/>
+        </a:xfrm>
+      </p:grpSpPr>
+      <p:sp>
+        <p:nvSpPr>
+          <p:cNvPr id="127" name="Google Shape;127;p25"/>
+          <p:cNvSpPr txBox="1"/>
+          <p:nvPr>
+            <p:ph type="title"/>
+          </p:nvPr>
+        </p:nvSpPr>
+        <p:spPr>
+          <a:xfrm>
+            <a:off x="311700" y="445025"/>
+            <a:ext cx="8520600" cy="572700"/>
+          </a:xfrm>
+          <a:prstGeom prst="rect">
+            <a:avLst/>
+          </a:prstGeom>
+          <a:noFill/>
+          <a:ln>
+            <a:noFill/>
+          </a:ln>
+        </p:spPr>
+        <p:txBody>
+          <a:bodyPr anchorCtr="0" anchor="t" bIns="91425" lIns="91425" spcFirstLastPara="1" rIns="91425" wrap="square" tIns="91425">
+            <a:normAutofit fontScale="90000"/>
+          </a:bodyPr>
+          <a:lstStyle/>
+          <a:p>
+            <a:pPr indent="0" lvl="0" marL="0" rtl="0" algn="l">
+              <a:lnSpc>
+                <a:spcPct val="100000"/>
+              </a:lnSpc>
+              <a:spcBef>
+                <a:spcPts val="0"/>
+              </a:spcBef>
+              <a:spcAft>
+                <a:spcPts val="0"/>
+              </a:spcAft>
+              <a:buSzPct val="111111"/>
+              <a:buNone/>
+            </a:pPr>
+            <a:r>
+              <a:rPr lang="hu"/>
+              <a:t>WPF Alkalmazás kinézete:</a:t>
+            </a:r>
+            <a:endParaRPr/>
+          </a:p>
+        </p:txBody>
+      </p:sp>
+      <p:pic>
+        <p:nvPicPr>
+          <p:cNvPr id="128" name="Google Shape;128;p25"/>
+          <p:cNvPicPr preferRelativeResize="0"/>
+          <p:nvPr/>
+        </p:nvPicPr>
+        <p:blipFill>
+          <a:blip r:embed="rId3">
+            <a:alphaModFix/>
+          </a:blip>
+          <a:stretch>
+            <a:fillRect/>
+          </a:stretch>
+        </p:blipFill>
+        <p:spPr>
+          <a:xfrm>
+            <a:off x="311700" y="1689850"/>
+            <a:ext cx="2326806" cy="2333700"/>
+          </a:xfrm>
+          <a:prstGeom prst="rect">
+            <a:avLst/>
+          </a:prstGeom>
+          <a:noFill/>
+          <a:ln>
+            <a:noFill/>
+          </a:ln>
+        </p:spPr>
+      </p:pic>
+      <p:pic>
+        <p:nvPicPr>
+          <p:cNvPr id="129" name="Google Shape;129;p25"/>
+          <p:cNvPicPr preferRelativeResize="0"/>
+          <p:nvPr/>
+        </p:nvPicPr>
+        <p:blipFill>
+          <a:blip r:embed="rId4">
+            <a:alphaModFix/>
+          </a:blip>
+          <a:stretch>
+            <a:fillRect/>
+          </a:stretch>
+        </p:blipFill>
+        <p:spPr>
+          <a:xfrm>
+            <a:off x="3053238" y="1689840"/>
+            <a:ext cx="2691750" cy="2333711"/>
+          </a:xfrm>
+          <a:prstGeom prst="rect">
+            <a:avLst/>
+          </a:prstGeom>
+          <a:noFill/>
+          <a:ln>
+            <a:noFill/>
+          </a:ln>
+        </p:spPr>
+      </p:pic>
+      <p:pic>
+        <p:nvPicPr>
+          <p:cNvPr id="130" name="Google Shape;130;p25"/>
+          <p:cNvPicPr preferRelativeResize="0"/>
+          <p:nvPr/>
+        </p:nvPicPr>
+        <p:blipFill>
+          <a:blip r:embed="rId5">
+            <a:alphaModFix/>
+          </a:blip>
+          <a:stretch>
+            <a:fillRect/>
+          </a:stretch>
+        </p:blipFill>
+        <p:spPr>
+          <a:xfrm>
+            <a:off x="6159725" y="1689850"/>
+            <a:ext cx="2672571" cy="2333700"/>
           </a:xfrm>
           <a:prstGeom prst="rect">
             <a:avLst/>
@@ -10197,10 +10738,10 @@
               <a:buNone/>
             </a:pPr>
             <a:r>
-              <a:rPr lang="hu"/>
+              <a:rPr lang="hu" sz="2000"/>
               <a:t>Mi vagyunk az Ételfutár. Üdvözöljük weblapunkon ahol kényelmesen rendelhet ételeket Miskolci éttermekből vagy akár egyéb városok éttermeiből. Cégünk étel rendeléssel és kiszállítással foglalkozik. Csak regisztráljon és már rendelhet is ételt házhoz azonnal. A kiszállítási díjat felszámoljuk amely 1000 Ft. Viszont cserébe kényelmesen, rugalmasan és friss ételt rendelhet tőlünk.</a:t>
             </a:r>
-            <a:endParaRPr/>
+            <a:endParaRPr sz="2000"/>
           </a:p>
         </p:txBody>
       </p:sp>
@@ -10288,7 +10829,7 @@
         <p:spPr>
           <a:xfrm>
             <a:off x="311700" y="1152475"/>
-            <a:ext cx="8520600" cy="3416400"/>
+            <a:ext cx="8520600" cy="3886500"/>
           </a:xfrm>
           <a:prstGeom prst="rect">
             <a:avLst/>
@@ -10300,21 +10841,21 @@
         </p:spPr>
         <p:txBody>
           <a:bodyPr anchorCtr="0" anchor="t" bIns="91425" lIns="91425" spcFirstLastPara="1" rIns="91425" wrap="square" tIns="91425">
-            <a:normAutofit fontScale="92500" lnSpcReduction="10000"/>
+            <a:noAutofit/>
           </a:bodyPr>
           <a:lstStyle/>
           <a:p>
             <a:pPr indent="0" lvl="0" marL="0" rtl="0" algn="l">
               <a:lnSpc>
-                <a:spcPct val="115000"/>
-              </a:lnSpc>
-              <a:spcBef>
-                <a:spcPts val="0"/>
-              </a:spcBef>
-              <a:spcAft>
-                <a:spcPts val="0"/>
-              </a:spcAft>
-              <a:buSzPct val="100000"/>
+                <a:spcPct val="105000"/>
+              </a:lnSpc>
+              <a:spcBef>
+                <a:spcPts val="0"/>
+              </a:spcBef>
+              <a:spcAft>
+                <a:spcPts val="0"/>
+              </a:spcAft>
+              <a:buSzPts val="1665"/>
               <a:buNone/>
             </a:pPr>
             <a:r>
@@ -10326,7 +10867,7 @@
           <a:p>
             <a:pPr indent="0" lvl="0" marL="0" rtl="0" algn="l">
               <a:lnSpc>
-                <a:spcPct val="115000"/>
+                <a:spcPct val="105000"/>
               </a:lnSpc>
               <a:spcBef>
                 <a:spcPts val="1200"/>
@@ -10334,7 +10875,7 @@
               <a:spcAft>
                 <a:spcPts val="0"/>
               </a:spcAft>
-              <a:buSzPct val="100000"/>
+              <a:buSzPts val="1665"/>
               <a:buNone/>
             </a:pPr>
             <a:r>
@@ -10346,7 +10887,7 @@
           <a:p>
             <a:pPr indent="0" lvl="0" marL="0" rtl="0" algn="l">
               <a:lnSpc>
-                <a:spcPct val="115000"/>
+                <a:spcPct val="105000"/>
               </a:lnSpc>
               <a:spcBef>
                 <a:spcPts val="1200"/>
@@ -10354,7 +10895,7 @@
               <a:spcAft>
                 <a:spcPts val="1200"/>
               </a:spcAft>
-              <a:buSzPct val="100000"/>
+              <a:buSzPts val="1665"/>
               <a:buNone/>
             </a:pPr>
             <a:r>
@@ -10730,13 +11271,12 @@
           <p:cNvPicPr preferRelativeResize="0"/>
           <p:nvPr/>
         </p:nvPicPr>
-        <p:blipFill>
+        <p:blipFill rotWithShape="1">
           <a:blip r:embed="rId3">
             <a:alphaModFix/>
           </a:blip>
-          <a:stretch>
-            <a:fillRect/>
-          </a:stretch>
+          <a:srcRect b="0" l="0" r="0" t="0"/>
+          <a:stretch/>
         </p:blipFill>
         <p:spPr>
           <a:xfrm>
@@ -11173,6 +11713,285 @@
 </file>
 
 <file path=ppt/theme/theme1.xml><?xml version="1.0" encoding="utf-8"?>
+<a:theme xmlns:a="http://schemas.openxmlformats.org/drawingml/2006/main" xmlns:r="http://schemas.openxmlformats.org/officeDocument/2006/relationships" name="Simple Light">
+  <a:themeElements>
+    <a:clrScheme name="Simple Light">
+      <a:dk1>
+        <a:srgbClr val="000000"/>
+      </a:dk1>
+      <a:lt1>
+        <a:srgbClr val="FFFFFF"/>
+      </a:lt1>
+      <a:dk2>
+        <a:srgbClr val="595959"/>
+      </a:dk2>
+      <a:lt2>
+        <a:srgbClr val="EEEEEE"/>
+      </a:lt2>
+      <a:accent1>
+        <a:srgbClr val="4285F4"/>
+      </a:accent1>
+      <a:accent2>
+        <a:srgbClr val="212121"/>
+      </a:accent2>
+      <a:accent3>
+        <a:srgbClr val="78909C"/>
+      </a:accent3>
+      <a:accent4>
+        <a:srgbClr val="FFAB40"/>
+      </a:accent4>
+      <a:accent5>
+        <a:srgbClr val="0097A7"/>
+      </a:accent5>
+      <a:accent6>
+        <a:srgbClr val="EEFF41"/>
+      </a:accent6>
+      <a:hlink>
+        <a:srgbClr val="0097A7"/>
+      </a:hlink>
+      <a:folHlink>
+        <a:srgbClr val="0097A7"/>
+      </a:folHlink>
+    </a:clrScheme>
+    <a:fontScheme name="Office">
+      <a:majorFont>
+        <a:latin typeface="Arial"/>
+        <a:ea typeface=""/>
+        <a:cs typeface=""/>
+        <a:font script="Jpan" typeface="ＭＳ Ｐゴシック"/>
+        <a:font script="Hang" typeface="맑은 고딕"/>
+        <a:font script="Hans" typeface="宋体"/>
+        <a:font script="Hant" typeface="新細明體"/>
+        <a:font script="Arab" typeface="Times New Roman"/>
+        <a:font script="Hebr" typeface="Times New Roman"/>
+        <a:font script="Thai" typeface="Angsana New"/>
+        <a:font script="Ethi" typeface="Nyala"/>
+        <a:font script="Beng" typeface="Vrinda"/>
+        <a:font script="Gujr" typeface="Shruti"/>
+        <a:font script="Khmr" typeface="MoolBoran"/>
+        <a:font script="Knda" typeface="Tunga"/>
+        <a:font script="Guru" typeface="Raavi"/>
+        <a:font script="Cans" typeface="Euphemia"/>
+        <a:font script="Cher" typeface="Plantagenet Cherokee"/>
+        <a:font script="Yiii" typeface="Microsoft Yi Baiti"/>
+        <a:font script="Tibt" typeface="Microsoft Himalaya"/>
+        <a:font script="Thaa" typeface="MV Boli"/>
+        <a:font script="Deva" typeface="Mangal"/>
+        <a:font script="Telu" typeface="Gautami"/>
+        <a:font script="Taml" typeface="Latha"/>
+        <a:font script="Syrc" typeface="Estrangelo Edessa"/>
+        <a:font script="Orya" typeface="Kalinga"/>
+        <a:font script="Mlym" typeface="Kartika"/>
+        <a:font script="Laoo" typeface="DokChampa"/>
+        <a:font script="Sinh" typeface="Iskoola Pota"/>
+        <a:font script="Mong" typeface="Mongolian Baiti"/>
+        <a:font script="Viet" typeface="Times New Roman"/>
+        <a:font script="Uigh" typeface="Microsoft Uighur"/>
+        <a:font script="Geor" typeface="Sylfaen"/>
+      </a:majorFont>
+      <a:minorFont>
+        <a:latin typeface="Arial"/>
+        <a:ea typeface=""/>
+        <a:cs typeface=""/>
+        <a:font script="Jpan" typeface="ＭＳ Ｐゴシック"/>
+        <a:font script="Hang" typeface="맑은 고딕"/>
+        <a:font script="Hans" typeface="宋体"/>
+        <a:font script="Hant" typeface="新細明體"/>
+        <a:font script="Arab" typeface="Arial"/>
+        <a:font script="Hebr" typeface="Arial"/>
+        <a:font script="Thai" typeface="Cordia New"/>
+        <a:font script="Ethi" typeface="Nyala"/>
+        <a:font script="Beng" typeface="Vrinda"/>
+        <a:font script="Gujr" typeface="Shruti"/>
+        <a:font script="Khmr" typeface="DaunPenh"/>
+        <a:font script="Knda" typeface="Tunga"/>
+        <a:font script="Guru" typeface="Raavi"/>
+        <a:font script="Cans" typeface="Euphemia"/>
+        <a:font script="Cher" typeface="Plantagenet Cherokee"/>
+        <a:font script="Yiii" typeface="Microsoft Yi Baiti"/>
+        <a:font script="Tibt" typeface="Microsoft Himalaya"/>
+        <a:font script="Thaa" typeface="MV Boli"/>
+        <a:font script="Deva" typeface="Mangal"/>
+        <a:font script="Telu" typeface="Gautami"/>
+        <a:font script="Taml" typeface="Latha"/>
+        <a:font script="Syrc" typeface="Estrangelo Edessa"/>
+        <a:font script="Orya" typeface="Kalinga"/>
+        <a:font script="Mlym" typeface="Kartika"/>
+        <a:font script="Laoo" typeface="DokChampa"/>
+        <a:font script="Sinh" typeface="Iskoola Pota"/>
+        <a:font script="Mong" typeface="Mongolian Baiti"/>
+        <a:font script="Viet" typeface="Arial"/>
+        <a:font script="Uigh" typeface="Microsoft Uighur"/>
+        <a:font script="Geor" typeface="Sylfaen"/>
+      </a:minorFont>
+    </a:fontScheme>
+    <a:fmtScheme name="Office">
+      <a:fillStyleLst>
+        <a:solidFill>
+          <a:schemeClr val="phClr"/>
+        </a:solidFill>
+        <a:gradFill rotWithShape="1">
+          <a:gsLst>
+            <a:gs pos="0">
+              <a:schemeClr val="phClr">
+                <a:tint val="50000"/>
+                <a:satMod val="300000"/>
+              </a:schemeClr>
+            </a:gs>
+            <a:gs pos="35000">
+              <a:schemeClr val="phClr">
+                <a:tint val="37000"/>
+                <a:satMod val="300000"/>
+              </a:schemeClr>
+            </a:gs>
+            <a:gs pos="100000">
+              <a:schemeClr val="phClr">
+                <a:tint val="15000"/>
+                <a:satMod val="350000"/>
+              </a:schemeClr>
+            </a:gs>
+          </a:gsLst>
+          <a:lin ang="16200000" scaled="1"/>
+        </a:gradFill>
+        <a:gradFill rotWithShape="1">
+          <a:gsLst>
+            <a:gs pos="0">
+              <a:schemeClr val="phClr">
+                <a:tint val="100000"/>
+                <a:shade val="100000"/>
+                <a:satMod val="130000"/>
+              </a:schemeClr>
+            </a:gs>
+            <a:gs pos="100000">
+              <a:schemeClr val="phClr">
+                <a:tint val="50000"/>
+                <a:shade val="100000"/>
+                <a:satMod val="350000"/>
+              </a:schemeClr>
+            </a:gs>
+          </a:gsLst>
+          <a:lin ang="16200000" scaled="0"/>
+        </a:gradFill>
+      </a:fillStyleLst>
+      <a:lnStyleLst>
+        <a:ln w="9525" cap="flat" cmpd="sng" algn="ctr">
+          <a:solidFill>
+            <a:schemeClr val="phClr">
+              <a:shade val="95000"/>
+              <a:satMod val="105000"/>
+            </a:schemeClr>
+          </a:solidFill>
+          <a:prstDash val="solid"/>
+        </a:ln>
+        <a:ln w="25400" cap="flat" cmpd="sng" algn="ctr">
+          <a:solidFill>
+            <a:schemeClr val="phClr"/>
+          </a:solidFill>
+          <a:prstDash val="solid"/>
+        </a:ln>
+        <a:ln w="38100" cap="flat" cmpd="sng" algn="ctr">
+          <a:solidFill>
+            <a:schemeClr val="phClr"/>
+          </a:solidFill>
+          <a:prstDash val="solid"/>
+        </a:ln>
+      </a:lnStyleLst>
+      <a:effectStyleLst>
+        <a:effectStyle>
+          <a:effectLst>
+            <a:outerShdw blurRad="40000" dist="20000" dir="5400000" rotWithShape="0">
+              <a:srgbClr val="000000">
+                <a:alpha val="38000"/>
+              </a:srgbClr>
+            </a:outerShdw>
+          </a:effectLst>
+        </a:effectStyle>
+        <a:effectStyle>
+          <a:effectLst>
+            <a:outerShdw blurRad="40000" dist="23000" dir="5400000" rotWithShape="0">
+              <a:srgbClr val="000000">
+                <a:alpha val="35000"/>
+              </a:srgbClr>
+            </a:outerShdw>
+          </a:effectLst>
+        </a:effectStyle>
+        <a:effectStyle>
+          <a:effectLst>
+            <a:outerShdw blurRad="40000" dist="23000" dir="5400000" rotWithShape="0">
+              <a:srgbClr val="000000">
+                <a:alpha val="35000"/>
+              </a:srgbClr>
+            </a:outerShdw>
+          </a:effectLst>
+          <a:scene3d>
+            <a:camera prst="orthographicFront">
+              <a:rot lat="0" lon="0" rev="0"/>
+            </a:camera>
+            <a:lightRig rig="threePt" dir="t">
+              <a:rot lat="0" lon="0" rev="1200000"/>
+            </a:lightRig>
+          </a:scene3d>
+          <a:sp3d>
+            <a:bevelT w="63500" h="25400"/>
+          </a:sp3d>
+        </a:effectStyle>
+      </a:effectStyleLst>
+      <a:bgFillStyleLst>
+        <a:solidFill>
+          <a:schemeClr val="phClr"/>
+        </a:solidFill>
+        <a:gradFill rotWithShape="1">
+          <a:gsLst>
+            <a:gs pos="0">
+              <a:schemeClr val="phClr">
+                <a:tint val="40000"/>
+                <a:satMod val="350000"/>
+              </a:schemeClr>
+            </a:gs>
+            <a:gs pos="40000">
+              <a:schemeClr val="phClr">
+                <a:tint val="45000"/>
+                <a:shade val="99000"/>
+                <a:satMod val="350000"/>
+              </a:schemeClr>
+            </a:gs>
+            <a:gs pos="100000">
+              <a:schemeClr val="phClr">
+                <a:shade val="20000"/>
+                <a:satMod val="255000"/>
+              </a:schemeClr>
+            </a:gs>
+          </a:gsLst>
+          <a:path path="circle">
+            <a:fillToRect l="50000" t="-80000" r="50000" b="180000"/>
+          </a:path>
+        </a:gradFill>
+        <a:gradFill rotWithShape="1">
+          <a:gsLst>
+            <a:gs pos="0">
+              <a:schemeClr val="phClr">
+                <a:tint val="80000"/>
+                <a:satMod val="300000"/>
+              </a:schemeClr>
+            </a:gs>
+            <a:gs pos="100000">
+              <a:schemeClr val="phClr">
+                <a:shade val="30000"/>
+                <a:satMod val="200000"/>
+              </a:schemeClr>
+            </a:gs>
+          </a:gsLst>
+          <a:path path="circle">
+            <a:fillToRect l="50000" t="50000" r="50000" b="50000"/>
+          </a:path>
+        </a:gradFill>
+      </a:bgFillStyleLst>
+    </a:fmtScheme>
+  </a:themeElements>
+</a:theme>
+</file>
+
+<file path=ppt/theme/theme2.xml><?xml version="1.0" encoding="utf-8"?>
 <a:theme xmlns:a="http://schemas.openxmlformats.org/drawingml/2006/main" xmlns:r="http://schemas.openxmlformats.org/officeDocument/2006/relationships">
   <a:themeElements>
     <a:clrScheme name="Default">
@@ -11449,283 +12268,4 @@
     </a:fmtScheme>
   </a:themeElements>
 </a:theme>
-</file>
-
-<file path=ppt/theme/theme2.xml><?xml version="1.0" encoding="utf-8"?>
-<a:theme xmlns:a="http://schemas.openxmlformats.org/drawingml/2006/main" xmlns:r="http://schemas.openxmlformats.org/officeDocument/2006/relationships" name="Simple Light">
-  <a:themeElements>
-    <a:clrScheme name="Simple Light">
-      <a:dk1>
-        <a:srgbClr val="000000"/>
-      </a:dk1>
-      <a:lt1>
-        <a:srgbClr val="FFFFFF"/>
-      </a:lt1>
-      <a:dk2>
-        <a:srgbClr val="595959"/>
-      </a:dk2>
-      <a:lt2>
-        <a:srgbClr val="EEEEEE"/>
-      </a:lt2>
-      <a:accent1>
-        <a:srgbClr val="4285F4"/>
-      </a:accent1>
-      <a:accent2>
-        <a:srgbClr val="212121"/>
-      </a:accent2>
-      <a:accent3>
-        <a:srgbClr val="78909C"/>
-      </a:accent3>
-      <a:accent4>
-        <a:srgbClr val="FFAB40"/>
-      </a:accent4>
-      <a:accent5>
-        <a:srgbClr val="0097A7"/>
-      </a:accent5>
-      <a:accent6>
-        <a:srgbClr val="EEFF41"/>
-      </a:accent6>
-      <a:hlink>
-        <a:srgbClr val="0097A7"/>
-      </a:hlink>
-      <a:folHlink>
-        <a:srgbClr val="0097A7"/>
-      </a:folHlink>
-    </a:clrScheme>
-    <a:fontScheme name="Office">
-      <a:majorFont>
-        <a:latin typeface="Arial"/>
-        <a:ea typeface=""/>
-        <a:cs typeface=""/>
-        <a:font script="Jpan" typeface="ＭＳ Ｐゴシック"/>
-        <a:font script="Hang" typeface="맑은 고딕"/>
-        <a:font script="Hans" typeface="宋体"/>
-        <a:font script="Hant" typeface="新細明體"/>
-        <a:font script="Arab" typeface="Times New Roman"/>
-        <a:font script="Hebr" typeface="Times New Roman"/>
-        <a:font script="Thai" typeface="Angsana New"/>
-        <a:font script="Ethi" typeface="Nyala"/>
-        <a:font script="Beng" typeface="Vrinda"/>
-        <a:font script="Gujr" typeface="Shruti"/>
-        <a:font script="Khmr" typeface="MoolBoran"/>
-        <a:font script="Knda" typeface="Tunga"/>
-        <a:font script="Guru" typeface="Raavi"/>
-        <a:font script="Cans" typeface="Euphemia"/>
-        <a:font script="Cher" typeface="Plantagenet Cherokee"/>
-        <a:font script="Yiii" typeface="Microsoft Yi Baiti"/>
-        <a:font script="Tibt" typeface="Microsoft Himalaya"/>
-        <a:font script="Thaa" typeface="MV Boli"/>
-        <a:font script="Deva" typeface="Mangal"/>
-        <a:font script="Telu" typeface="Gautami"/>
-        <a:font script="Taml" typeface="Latha"/>
-        <a:font script="Syrc" typeface="Estrangelo Edessa"/>
-        <a:font script="Orya" typeface="Kalinga"/>
-        <a:font script="Mlym" typeface="Kartika"/>
-        <a:font script="Laoo" typeface="DokChampa"/>
-        <a:font script="Sinh" typeface="Iskoola Pota"/>
-        <a:font script="Mong" typeface="Mongolian Baiti"/>
-        <a:font script="Viet" typeface="Times New Roman"/>
-        <a:font script="Uigh" typeface="Microsoft Uighur"/>
-        <a:font script="Geor" typeface="Sylfaen"/>
-      </a:majorFont>
-      <a:minorFont>
-        <a:latin typeface="Arial"/>
-        <a:ea typeface=""/>
-        <a:cs typeface=""/>
-        <a:font script="Jpan" typeface="ＭＳ Ｐゴシック"/>
-        <a:font script="Hang" typeface="맑은 고딕"/>
-        <a:font script="Hans" typeface="宋体"/>
-        <a:font script="Hant" typeface="新細明體"/>
-        <a:font script="Arab" typeface="Arial"/>
-        <a:font script="Hebr" typeface="Arial"/>
-        <a:font script="Thai" typeface="Cordia New"/>
-        <a:font script="Ethi" typeface="Nyala"/>
-        <a:font script="Beng" typeface="Vrinda"/>
-        <a:font script="Gujr" typeface="Shruti"/>
-        <a:font script="Khmr" typeface="DaunPenh"/>
-        <a:font script="Knda" typeface="Tunga"/>
-        <a:font script="Guru" typeface="Raavi"/>
-        <a:font script="Cans" typeface="Euphemia"/>
-        <a:font script="Cher" typeface="Plantagenet Cherokee"/>
-        <a:font script="Yiii" typeface="Microsoft Yi Baiti"/>
-        <a:font script="Tibt" typeface="Microsoft Himalaya"/>
-        <a:font script="Thaa" typeface="MV Boli"/>
-        <a:font script="Deva" typeface="Mangal"/>
-        <a:font script="Telu" typeface="Gautami"/>
-        <a:font script="Taml" typeface="Latha"/>
-        <a:font script="Syrc" typeface="Estrangelo Edessa"/>
-        <a:font script="Orya" typeface="Kalinga"/>
-        <a:font script="Mlym" typeface="Kartika"/>
-        <a:font script="Laoo" typeface="DokChampa"/>
-        <a:font script="Sinh" typeface="Iskoola Pota"/>
-        <a:font script="Mong" typeface="Mongolian Baiti"/>
-        <a:font script="Viet" typeface="Arial"/>
-        <a:font script="Uigh" typeface="Microsoft Uighur"/>
-        <a:font script="Geor" typeface="Sylfaen"/>
-      </a:minorFont>
-    </a:fontScheme>
-    <a:fmtScheme name="Office">
-      <a:fillStyleLst>
-        <a:solidFill>
-          <a:schemeClr val="phClr"/>
-        </a:solidFill>
-        <a:gradFill rotWithShape="1">
-          <a:gsLst>
-            <a:gs pos="0">
-              <a:schemeClr val="phClr">
-                <a:tint val="50000"/>
-                <a:satMod val="300000"/>
-              </a:schemeClr>
-            </a:gs>
-            <a:gs pos="35000">
-              <a:schemeClr val="phClr">
-                <a:tint val="37000"/>
-                <a:satMod val="300000"/>
-              </a:schemeClr>
-            </a:gs>
-            <a:gs pos="100000">
-              <a:schemeClr val="phClr">
-                <a:tint val="15000"/>
-                <a:satMod val="350000"/>
-              </a:schemeClr>
-            </a:gs>
-          </a:gsLst>
-          <a:lin ang="16200000" scaled="1"/>
-        </a:gradFill>
-        <a:gradFill rotWithShape="1">
-          <a:gsLst>
-            <a:gs pos="0">
-              <a:schemeClr val="phClr">
-                <a:tint val="100000"/>
-                <a:shade val="100000"/>
-                <a:satMod val="130000"/>
-              </a:schemeClr>
-            </a:gs>
-            <a:gs pos="100000">
-              <a:schemeClr val="phClr">
-                <a:tint val="50000"/>
-                <a:shade val="100000"/>
-                <a:satMod val="350000"/>
-              </a:schemeClr>
-            </a:gs>
-          </a:gsLst>
-          <a:lin ang="16200000" scaled="0"/>
-        </a:gradFill>
-      </a:fillStyleLst>
-      <a:lnStyleLst>
-        <a:ln w="9525" cap="flat" cmpd="sng" algn="ctr">
-          <a:solidFill>
-            <a:schemeClr val="phClr">
-              <a:shade val="95000"/>
-              <a:satMod val="105000"/>
-            </a:schemeClr>
-          </a:solidFill>
-          <a:prstDash val="solid"/>
-        </a:ln>
-        <a:ln w="25400" cap="flat" cmpd="sng" algn="ctr">
-          <a:solidFill>
-            <a:schemeClr val="phClr"/>
-          </a:solidFill>
-          <a:prstDash val="solid"/>
-        </a:ln>
-        <a:ln w="38100" cap="flat" cmpd="sng" algn="ctr">
-          <a:solidFill>
-            <a:schemeClr val="phClr"/>
-          </a:solidFill>
-          <a:prstDash val="solid"/>
-        </a:ln>
-      </a:lnStyleLst>
-      <a:effectStyleLst>
-        <a:effectStyle>
-          <a:effectLst>
-            <a:outerShdw blurRad="40000" dist="20000" dir="5400000" rotWithShape="0">
-              <a:srgbClr val="000000">
-                <a:alpha val="38000"/>
-              </a:srgbClr>
-            </a:outerShdw>
-          </a:effectLst>
-        </a:effectStyle>
-        <a:effectStyle>
-          <a:effectLst>
-            <a:outerShdw blurRad="40000" dist="23000" dir="5400000" rotWithShape="0">
-              <a:srgbClr val="000000">
-                <a:alpha val="35000"/>
-              </a:srgbClr>
-            </a:outerShdw>
-          </a:effectLst>
-        </a:effectStyle>
-        <a:effectStyle>
-          <a:effectLst>
-            <a:outerShdw blurRad="40000" dist="23000" dir="5400000" rotWithShape="0">
-              <a:srgbClr val="000000">
-                <a:alpha val="35000"/>
-              </a:srgbClr>
-            </a:outerShdw>
-          </a:effectLst>
-          <a:scene3d>
-            <a:camera prst="orthographicFront">
-              <a:rot lat="0" lon="0" rev="0"/>
-            </a:camera>
-            <a:lightRig rig="threePt" dir="t">
-              <a:rot lat="0" lon="0" rev="1200000"/>
-            </a:lightRig>
-          </a:scene3d>
-          <a:sp3d>
-            <a:bevelT w="63500" h="25400"/>
-          </a:sp3d>
-        </a:effectStyle>
-      </a:effectStyleLst>
-      <a:bgFillStyleLst>
-        <a:solidFill>
-          <a:schemeClr val="phClr"/>
-        </a:solidFill>
-        <a:gradFill rotWithShape="1">
-          <a:gsLst>
-            <a:gs pos="0">
-              <a:schemeClr val="phClr">
-                <a:tint val="40000"/>
-                <a:satMod val="350000"/>
-              </a:schemeClr>
-            </a:gs>
-            <a:gs pos="40000">
-              <a:schemeClr val="phClr">
-                <a:tint val="45000"/>
-                <a:shade val="99000"/>
-                <a:satMod val="350000"/>
-              </a:schemeClr>
-            </a:gs>
-            <a:gs pos="100000">
-              <a:schemeClr val="phClr">
-                <a:shade val="20000"/>
-                <a:satMod val="255000"/>
-              </a:schemeClr>
-            </a:gs>
-          </a:gsLst>
-          <a:path path="circle">
-            <a:fillToRect l="50000" t="-80000" r="50000" b="180000"/>
-          </a:path>
-        </a:gradFill>
-        <a:gradFill rotWithShape="1">
-          <a:gsLst>
-            <a:gs pos="0">
-              <a:schemeClr val="phClr">
-                <a:tint val="80000"/>
-                <a:satMod val="300000"/>
-              </a:schemeClr>
-            </a:gs>
-            <a:gs pos="100000">
-              <a:schemeClr val="phClr">
-                <a:shade val="30000"/>
-                <a:satMod val="200000"/>
-              </a:schemeClr>
-            </a:gs>
-          </a:gsLst>
-          <a:path path="circle">
-            <a:fillToRect l="50000" t="50000" r="50000" b="50000"/>
-          </a:path>
-        </a:gradFill>
-      </a:bgFillStyleLst>
-    </a:fmtScheme>
-  </a:themeElements>
-</a:theme>
 </file>
</xml_diff>

<commit_message>
Power Point Prezentáció frissítve
</commit_message>
<xml_diff>
--- a/etelfutar_ppt_uj.pptx
+++ b/etelfutar_ppt_uj.pptx
@@ -24,6 +24,8 @@
     <p:sldId id="269" r:id="rId19"/>
     <p:sldId id="270" r:id="rId20"/>
     <p:sldId id="271" r:id="rId21"/>
+    <p:sldId id="272" r:id="rId22"/>
+    <p:sldId id="273" r:id="rId23"/>
   </p:sldIdLst>
   <p:sldSz cy="5143500" cx="9144000"/>
   <p:notesSz cx="6858000" cy="9144000"/>
@@ -972,7 +974,7 @@
       </p:grpSpPr>
       <p:sp>
         <p:nvSpPr>
-          <p:cNvPr id="106" name="Google Shape;106;p10:notes"/>
+          <p:cNvPr id="106" name="Google Shape;106;p8:notes"/>
           <p:cNvSpPr/>
           <p:nvPr>
             <p:ph idx="2" type="sldImg"/>
@@ -1017,7 +1019,7 @@
       </p:sp>
       <p:sp>
         <p:nvSpPr>
-          <p:cNvPr id="107" name="Google Shape;107;p10:notes"/>
+          <p:cNvPr id="107" name="Google Shape;107;p8:notes"/>
           <p:cNvSpPr txBox="1"/>
           <p:nvPr>
             <p:ph idx="1" type="body"/>
@@ -1089,7 +1091,7 @@
       </p:grpSpPr>
       <p:sp>
         <p:nvSpPr>
-          <p:cNvPr id="112" name="Google Shape;112;p11:notes"/>
+          <p:cNvPr id="112" name="Google Shape;112;p9:notes"/>
           <p:cNvSpPr/>
           <p:nvPr>
             <p:ph idx="2" type="sldImg"/>
@@ -1134,7 +1136,7 @@
       </p:sp>
       <p:sp>
         <p:nvSpPr>
-          <p:cNvPr id="113" name="Google Shape;113;p11:notes"/>
+          <p:cNvPr id="113" name="Google Shape;113;p9:notes"/>
           <p:cNvSpPr txBox="1"/>
           <p:nvPr>
             <p:ph idx="1" type="body"/>
@@ -1206,7 +1208,7 @@
       </p:grpSpPr>
       <p:sp>
         <p:nvSpPr>
-          <p:cNvPr id="118" name="Google Shape;118;p12:notes"/>
+          <p:cNvPr id="118" name="Google Shape;118;p10:notes"/>
           <p:cNvSpPr/>
           <p:nvPr>
             <p:ph idx="2" type="sldImg"/>
@@ -1251,7 +1253,7 @@
       </p:sp>
       <p:sp>
         <p:nvSpPr>
-          <p:cNvPr id="119" name="Google Shape;119;p12:notes"/>
+          <p:cNvPr id="119" name="Google Shape;119;p10:notes"/>
           <p:cNvSpPr txBox="1"/>
           <p:nvPr>
             <p:ph idx="1" type="body"/>
@@ -1323,7 +1325,7 @@
       </p:grpSpPr>
       <p:sp>
         <p:nvSpPr>
-          <p:cNvPr id="124" name="Google Shape;124;p13:notes"/>
+          <p:cNvPr id="124" name="Google Shape;124;p11:notes"/>
           <p:cNvSpPr/>
           <p:nvPr>
             <p:ph idx="2" type="sldImg"/>
@@ -1368,7 +1370,7 @@
       </p:sp>
       <p:sp>
         <p:nvSpPr>
-          <p:cNvPr id="125" name="Google Shape;125;p13:notes"/>
+          <p:cNvPr id="125" name="Google Shape;125;p11:notes"/>
           <p:cNvSpPr txBox="1"/>
           <p:nvPr>
             <p:ph idx="1" type="body"/>
@@ -1440,7 +1442,7 @@
       </p:grpSpPr>
       <p:sp>
         <p:nvSpPr>
-          <p:cNvPr id="130" name="Google Shape;130;p14:notes"/>
+          <p:cNvPr id="130" name="Google Shape;130;p12:notes"/>
           <p:cNvSpPr/>
           <p:nvPr>
             <p:ph idx="2" type="sldImg"/>
@@ -1485,7 +1487,7 @@
       </p:sp>
       <p:sp>
         <p:nvSpPr>
-          <p:cNvPr id="131" name="Google Shape;131;p14:notes"/>
+          <p:cNvPr id="131" name="Google Shape;131;p12:notes"/>
           <p:cNvSpPr txBox="1"/>
           <p:nvPr>
             <p:ph idx="1" type="body"/>
@@ -1557,7 +1559,7 @@
       </p:grpSpPr>
       <p:sp>
         <p:nvSpPr>
-          <p:cNvPr id="136" name="Google Shape;136;g2dcd20e16e9_0_3:notes"/>
+          <p:cNvPr id="136" name="Google Shape;136;p13:notes"/>
           <p:cNvSpPr/>
           <p:nvPr>
             <p:ph idx="2" type="sldImg"/>
@@ -1602,7 +1604,7 @@
       </p:sp>
       <p:sp>
         <p:nvSpPr>
-          <p:cNvPr id="137" name="Google Shape;137;g2dcd20e16e9_0_3:notes"/>
+          <p:cNvPr id="137" name="Google Shape;137;p13:notes"/>
           <p:cNvSpPr txBox="1"/>
           <p:nvPr>
             <p:ph idx="1" type="body"/>
@@ -1660,7 +1662,7 @@
   <p:cSld>
     <p:spTree>
       <p:nvGrpSpPr>
-        <p:cNvPr id="142" name="Shape 142"/>
+        <p:cNvPr id="141" name="Shape 141"/>
         <p:cNvGrpSpPr/>
         <p:nvPr/>
       </p:nvGrpSpPr>
@@ -1674,7 +1676,7 @@
       </p:grpSpPr>
       <p:sp>
         <p:nvSpPr>
-          <p:cNvPr id="143" name="Google Shape;143;p15:notes"/>
+          <p:cNvPr id="142" name="Google Shape;142;p14:notes"/>
           <p:cNvSpPr/>
           <p:nvPr>
             <p:ph idx="2" type="sldImg"/>
@@ -1719,7 +1721,241 @@
       </p:sp>
       <p:sp>
         <p:nvSpPr>
-          <p:cNvPr id="144" name="Google Shape;144;p15:notes"/>
+          <p:cNvPr id="143" name="Google Shape;143;p14:notes"/>
+          <p:cNvSpPr txBox="1"/>
+          <p:nvPr>
+            <p:ph idx="1" type="body"/>
+          </p:nvPr>
+        </p:nvSpPr>
+        <p:spPr>
+          <a:xfrm>
+            <a:off x="685800" y="4343400"/>
+            <a:ext cx="5486400" cy="4114800"/>
+          </a:xfrm>
+          <a:prstGeom prst="rect">
+            <a:avLst/>
+          </a:prstGeom>
+          <a:noFill/>
+          <a:ln>
+            <a:noFill/>
+          </a:ln>
+        </p:spPr>
+        <p:txBody>
+          <a:bodyPr anchorCtr="0" anchor="t" bIns="91425" lIns="91425" spcFirstLastPara="1" rIns="91425" wrap="square" tIns="91425">
+            <a:noAutofit/>
+          </a:bodyPr>
+          <a:lstStyle/>
+          <a:p>
+            <a:pPr indent="0" lvl="0" marL="0" rtl="0" algn="l">
+              <a:lnSpc>
+                <a:spcPct val="100000"/>
+              </a:lnSpc>
+              <a:spcBef>
+                <a:spcPts val="0"/>
+              </a:spcBef>
+              <a:spcAft>
+                <a:spcPts val="0"/>
+              </a:spcAft>
+              <a:buSzPts val="1100"/>
+              <a:buNone/>
+            </a:pPr>
+            <a:r>
+              <a:t/>
+            </a:r>
+            <a:endParaRPr/>
+          </a:p>
+        </p:txBody>
+      </p:sp>
+    </p:spTree>
+  </p:cSld>
+  <p:clrMapOvr>
+    <a:masterClrMapping/>
+  </p:clrMapOvr>
+</p:notes>
+</file>
+
+<file path=ppt/notesSlides/notesSlide17.xml><?xml version="1.0" encoding="utf-8"?>
+<p:notes xmlns:a="http://schemas.openxmlformats.org/drawingml/2006/main" xmlns:r="http://schemas.openxmlformats.org/officeDocument/2006/relationships" xmlns:mc="http://schemas.openxmlformats.org/markup-compatibility/2006" xmlns:mv="urn:schemas-microsoft-com:mac:vml" xmlns:p="http://schemas.openxmlformats.org/presentationml/2006/main" xmlns:c="http://schemas.openxmlformats.org/drawingml/2006/chart" xmlns:dgm="http://schemas.openxmlformats.org/drawingml/2006/diagram" xmlns:o="urn:schemas-microsoft-com:office:office" xmlns:v="urn:schemas-microsoft-com:vml" xmlns:pvml="urn:schemas-microsoft-com:office:powerpoint" xmlns:com="http://schemas.openxmlformats.org/drawingml/2006/compatibility" xmlns:p14="http://schemas.microsoft.com/office/powerpoint/2010/main" xmlns:p15="http://schemas.microsoft.com/office/powerpoint/2012/main" xmlns:ahyp="http://schemas.microsoft.com/office/drawing/2018/hyperlinkcolor" showMasterPhAnim="0" showMasterSp="0">
+  <p:cSld>
+    <p:spTree>
+      <p:nvGrpSpPr>
+        <p:cNvPr id="147" name="Shape 147"/>
+        <p:cNvGrpSpPr/>
+        <p:nvPr/>
+      </p:nvGrpSpPr>
+      <p:grpSpPr>
+        <a:xfrm>
+          <a:off x="0" y="0"/>
+          <a:ext cx="0" cy="0"/>
+          <a:chOff x="0" y="0"/>
+          <a:chExt cx="0" cy="0"/>
+        </a:xfrm>
+      </p:grpSpPr>
+      <p:sp>
+        <p:nvSpPr>
+          <p:cNvPr id="148" name="Google Shape;148;p15:notes"/>
+          <p:cNvSpPr/>
+          <p:nvPr>
+            <p:ph idx="2" type="sldImg"/>
+          </p:nvPr>
+        </p:nvSpPr>
+        <p:spPr>
+          <a:xfrm>
+            <a:off x="381300" y="685800"/>
+            <a:ext cx="6096000" cy="3429000"/>
+          </a:xfrm>
+          <a:custGeom>
+            <a:rect b="b" l="l" r="r" t="t"/>
+            <a:pathLst>
+              <a:path extrusionOk="0" h="120000" w="120000">
+                <a:moveTo>
+                  <a:pt x="0" y="0"/>
+                </a:moveTo>
+                <a:lnTo>
+                  <a:pt x="120000" y="0"/>
+                </a:lnTo>
+                <a:lnTo>
+                  <a:pt x="120000" y="120000"/>
+                </a:lnTo>
+                <a:lnTo>
+                  <a:pt x="0" y="120000"/>
+                </a:lnTo>
+                <a:close/>
+              </a:path>
+            </a:pathLst>
+          </a:custGeom>
+          <a:noFill/>
+          <a:ln cap="flat" cmpd="sng" w="9525">
+            <a:solidFill>
+              <a:srgbClr val="000000"/>
+            </a:solidFill>
+            <a:prstDash val="solid"/>
+            <a:round/>
+            <a:headEnd len="sm" w="sm" type="none"/>
+            <a:tailEnd len="sm" w="sm" type="none"/>
+          </a:ln>
+        </p:spPr>
+      </p:sp>
+      <p:sp>
+        <p:nvSpPr>
+          <p:cNvPr id="149" name="Google Shape;149;p15:notes"/>
+          <p:cNvSpPr txBox="1"/>
+          <p:nvPr>
+            <p:ph idx="1" type="body"/>
+          </p:nvPr>
+        </p:nvSpPr>
+        <p:spPr>
+          <a:xfrm>
+            <a:off x="685800" y="4343400"/>
+            <a:ext cx="5486400" cy="4114800"/>
+          </a:xfrm>
+          <a:prstGeom prst="rect">
+            <a:avLst/>
+          </a:prstGeom>
+          <a:noFill/>
+          <a:ln>
+            <a:noFill/>
+          </a:ln>
+        </p:spPr>
+        <p:txBody>
+          <a:bodyPr anchorCtr="0" anchor="t" bIns="91425" lIns="91425" spcFirstLastPara="1" rIns="91425" wrap="square" tIns="91425">
+            <a:noAutofit/>
+          </a:bodyPr>
+          <a:lstStyle/>
+          <a:p>
+            <a:pPr indent="0" lvl="0" marL="0" rtl="0" algn="l">
+              <a:lnSpc>
+                <a:spcPct val="100000"/>
+              </a:lnSpc>
+              <a:spcBef>
+                <a:spcPts val="0"/>
+              </a:spcBef>
+              <a:spcAft>
+                <a:spcPts val="0"/>
+              </a:spcAft>
+              <a:buSzPts val="1100"/>
+              <a:buNone/>
+            </a:pPr>
+            <a:r>
+              <a:t/>
+            </a:r>
+            <a:endParaRPr/>
+          </a:p>
+        </p:txBody>
+      </p:sp>
+    </p:spTree>
+  </p:cSld>
+  <p:clrMapOvr>
+    <a:masterClrMapping/>
+  </p:clrMapOvr>
+</p:notes>
+</file>
+
+<file path=ppt/notesSlides/notesSlide18.xml><?xml version="1.0" encoding="utf-8"?>
+<p:notes xmlns:a="http://schemas.openxmlformats.org/drawingml/2006/main" xmlns:r="http://schemas.openxmlformats.org/officeDocument/2006/relationships" xmlns:mc="http://schemas.openxmlformats.org/markup-compatibility/2006" xmlns:mv="urn:schemas-microsoft-com:mac:vml" xmlns:p="http://schemas.openxmlformats.org/presentationml/2006/main" xmlns:c="http://schemas.openxmlformats.org/drawingml/2006/chart" xmlns:dgm="http://schemas.openxmlformats.org/drawingml/2006/diagram" xmlns:o="urn:schemas-microsoft-com:office:office" xmlns:v="urn:schemas-microsoft-com:vml" xmlns:pvml="urn:schemas-microsoft-com:office:powerpoint" xmlns:com="http://schemas.openxmlformats.org/drawingml/2006/compatibility" xmlns:p14="http://schemas.microsoft.com/office/powerpoint/2010/main" xmlns:p15="http://schemas.microsoft.com/office/powerpoint/2012/main" xmlns:ahyp="http://schemas.microsoft.com/office/drawing/2018/hyperlinkcolor" showMasterPhAnim="0" showMasterSp="0">
+  <p:cSld>
+    <p:spTree>
+      <p:nvGrpSpPr>
+        <p:cNvPr id="154" name="Shape 154"/>
+        <p:cNvGrpSpPr/>
+        <p:nvPr/>
+      </p:nvGrpSpPr>
+      <p:grpSpPr>
+        <a:xfrm>
+          <a:off x="0" y="0"/>
+          <a:ext cx="0" cy="0"/>
+          <a:chOff x="0" y="0"/>
+          <a:chExt cx="0" cy="0"/>
+        </a:xfrm>
+      </p:grpSpPr>
+      <p:sp>
+        <p:nvSpPr>
+          <p:cNvPr id="155" name="Google Shape;155;p16:notes"/>
+          <p:cNvSpPr/>
+          <p:nvPr>
+            <p:ph idx="2" type="sldImg"/>
+          </p:nvPr>
+        </p:nvSpPr>
+        <p:spPr>
+          <a:xfrm>
+            <a:off x="381300" y="685800"/>
+            <a:ext cx="6096000" cy="3429000"/>
+          </a:xfrm>
+          <a:custGeom>
+            <a:rect b="b" l="l" r="r" t="t"/>
+            <a:pathLst>
+              <a:path extrusionOk="0" h="120000" w="120000">
+                <a:moveTo>
+                  <a:pt x="0" y="0"/>
+                </a:moveTo>
+                <a:lnTo>
+                  <a:pt x="120000" y="0"/>
+                </a:lnTo>
+                <a:lnTo>
+                  <a:pt x="120000" y="120000"/>
+                </a:lnTo>
+                <a:lnTo>
+                  <a:pt x="0" y="120000"/>
+                </a:lnTo>
+                <a:close/>
+              </a:path>
+            </a:pathLst>
+          </a:custGeom>
+          <a:noFill/>
+          <a:ln cap="flat" cmpd="sng" w="9525">
+            <a:solidFill>
+              <a:srgbClr val="000000"/>
+            </a:solidFill>
+            <a:prstDash val="solid"/>
+            <a:round/>
+            <a:headEnd len="sm" w="sm" type="none"/>
+            <a:tailEnd len="sm" w="sm" type="none"/>
+          </a:ln>
+        </p:spPr>
+      </p:sp>
+      <p:sp>
+        <p:nvSpPr>
+          <p:cNvPr id="156" name="Google Shape;156;p16:notes"/>
           <p:cNvSpPr txBox="1"/>
           <p:nvPr>
             <p:ph idx="1" type="body"/>
@@ -2259,7 +2495,7 @@
       </p:grpSpPr>
       <p:sp>
         <p:nvSpPr>
-          <p:cNvPr id="81" name="Google Shape;81;p6:notes"/>
+          <p:cNvPr id="81" name="Google Shape;81;g33c8b4a7e33_0_0:notes"/>
           <p:cNvSpPr/>
           <p:nvPr>
             <p:ph idx="2" type="sldImg"/>
@@ -2304,7 +2540,7 @@
       </p:sp>
       <p:sp>
         <p:nvSpPr>
-          <p:cNvPr id="82" name="Google Shape;82;p6:notes"/>
+          <p:cNvPr id="82" name="Google Shape;82;g33c8b4a7e33_0_0:notes"/>
           <p:cNvSpPr txBox="1"/>
           <p:nvPr>
             <p:ph idx="1" type="body"/>
@@ -2362,7 +2598,7 @@
   <p:cSld>
     <p:spTree>
       <p:nvGrpSpPr>
-        <p:cNvPr id="87" name="Shape 87"/>
+        <p:cNvPr id="86" name="Shape 86"/>
         <p:cNvGrpSpPr/>
         <p:nvPr/>
       </p:nvGrpSpPr>
@@ -2376,7 +2612,7 @@
       </p:grpSpPr>
       <p:sp>
         <p:nvSpPr>
-          <p:cNvPr id="88" name="Google Shape;88;p7:notes"/>
+          <p:cNvPr id="87" name="Google Shape;87;g33c8b4a7e33_0_6:notes"/>
           <p:cNvSpPr/>
           <p:nvPr>
             <p:ph idx="2" type="sldImg"/>
@@ -2421,7 +2657,7 @@
       </p:sp>
       <p:sp>
         <p:nvSpPr>
-          <p:cNvPr id="89" name="Google Shape;89;p7:notes"/>
+          <p:cNvPr id="88" name="Google Shape;88;g33c8b4a7e33_0_6:notes"/>
           <p:cNvSpPr txBox="1"/>
           <p:nvPr>
             <p:ph idx="1" type="body"/>
@@ -2479,7 +2715,7 @@
   <p:cSld>
     <p:spTree>
       <p:nvGrpSpPr>
-        <p:cNvPr id="93" name="Shape 93"/>
+        <p:cNvPr id="92" name="Shape 92"/>
         <p:cNvGrpSpPr/>
         <p:nvPr/>
       </p:nvGrpSpPr>
@@ -2493,7 +2729,7 @@
       </p:grpSpPr>
       <p:sp>
         <p:nvSpPr>
-          <p:cNvPr id="94" name="Google Shape;94;p8:notes"/>
+          <p:cNvPr id="93" name="Google Shape;93;p6:notes"/>
           <p:cNvSpPr/>
           <p:nvPr>
             <p:ph idx="2" type="sldImg"/>
@@ -2538,7 +2774,7 @@
       </p:sp>
       <p:sp>
         <p:nvSpPr>
-          <p:cNvPr id="95" name="Google Shape;95;p8:notes"/>
+          <p:cNvPr id="94" name="Google Shape;94;p6:notes"/>
           <p:cNvSpPr txBox="1"/>
           <p:nvPr>
             <p:ph idx="1" type="body"/>
@@ -2610,7 +2846,7 @@
       </p:grpSpPr>
       <p:sp>
         <p:nvSpPr>
-          <p:cNvPr id="100" name="Google Shape;100;p9:notes"/>
+          <p:cNvPr id="100" name="Google Shape;100;p7:notes"/>
           <p:cNvSpPr/>
           <p:nvPr>
             <p:ph idx="2" type="sldImg"/>
@@ -2655,7 +2891,7 @@
       </p:sp>
       <p:sp>
         <p:nvSpPr>
-          <p:cNvPr id="101" name="Google Shape;101;p9:notes"/>
+          <p:cNvPr id="101" name="Google Shape;101;p7:notes"/>
           <p:cNvSpPr txBox="1"/>
           <p:nvPr>
             <p:ph idx="1" type="body"/>
@@ -10540,7 +10776,7 @@
             </a:pPr>
             <a:r>
               <a:rPr lang="hu"/>
-              <a:t>Ételfutár Weboldalnak a Miskolci Éttermek Rácsszerkezete:</a:t>
+              <a:t>Ételfutár Weboldalnak a Regisztrálás Rácsszerkezete:</a:t>
             </a:r>
             <a:endParaRPr/>
           </a:p>
@@ -10561,8 +10797,8 @@
         </p:blipFill>
         <p:spPr>
           <a:xfrm>
-            <a:off x="3305925" y="1170125"/>
-            <a:ext cx="5087062" cy="3820974"/>
+            <a:off x="152400" y="1170125"/>
+            <a:ext cx="5088948" cy="3820975"/>
           </a:xfrm>
           <a:prstGeom prst="rect">
             <a:avLst/>
@@ -10644,7 +10880,7 @@
             </a:pPr>
             <a:r>
               <a:rPr lang="hu"/>
-              <a:t>Ételfutár Weboldalnak a Kosár Rácsszerkezete:</a:t>
+              <a:t>Ételfutár Weboldalnak a Bejelentkezés Rácsszerkezete:</a:t>
             </a:r>
             <a:endParaRPr/>
           </a:p>
@@ -10739,12 +10975,16 @@
               <a:spcAft>
                 <a:spcPts val="0"/>
               </a:spcAft>
-              <a:buSzPct val="111111"/>
+              <a:buClr>
+                <a:schemeClr val="dk1"/>
+              </a:buClr>
+              <a:buSzPct val="39285"/>
+              <a:buFont typeface="Arial"/>
               <a:buNone/>
             </a:pPr>
             <a:r>
               <a:rPr lang="hu"/>
-              <a:t>Ételfutár Weboldal jelenlegi állapota, kinézete:</a:t>
+              <a:t>Ételfutár Weboldalnak a Miskolci Éttermek Rácsszerkezete:</a:t>
             </a:r>
             <a:endParaRPr/>
           </a:p>
@@ -10765,8 +11005,8 @@
         </p:blipFill>
         <p:spPr>
           <a:xfrm>
-            <a:off x="152400" y="1170125"/>
-            <a:ext cx="8079595" cy="3820975"/>
+            <a:off x="3305925" y="1170125"/>
+            <a:ext cx="5087062" cy="3820974"/>
           </a:xfrm>
           <a:prstGeom prst="rect">
             <a:avLst/>
@@ -10839,27 +11079,38 @@
               <a:spcAft>
                 <a:spcPts val="0"/>
               </a:spcAft>
-              <a:buSzPct val="111111"/>
+              <a:buClr>
+                <a:schemeClr val="dk1"/>
+              </a:buClr>
+              <a:buSzPct val="39285"/>
+              <a:buFont typeface="Arial"/>
               <a:buNone/>
             </a:pPr>
             <a:r>
               <a:rPr lang="hu"/>
-              <a:t>Adminisztrációs felület-WPF Alkalmazás:</a:t>
+              <a:t>Ételfutár Weboldalnak a Kosár Rácsszerkezete:</a:t>
             </a:r>
             <a:endParaRPr/>
           </a:p>
         </p:txBody>
       </p:sp>
-      <p:sp>
-        <p:nvSpPr>
+      <p:pic>
+        <p:nvPicPr>
           <p:cNvPr id="128" name="Google Shape;128;p25"/>
-          <p:cNvSpPr txBox="1"/>
+          <p:cNvPicPr preferRelativeResize="0"/>
           <p:nvPr/>
-        </p:nvSpPr>
+        </p:nvPicPr>
+        <p:blipFill rotWithShape="1">
+          <a:blip r:embed="rId3">
+            <a:alphaModFix/>
+          </a:blip>
+          <a:srcRect b="0" l="0" r="0" t="0"/>
+          <a:stretch/>
+        </p:blipFill>
         <p:spPr>
           <a:xfrm>
-            <a:off x="311700" y="1017725"/>
-            <a:ext cx="8335500" cy="1723800"/>
+            <a:off x="152400" y="1170125"/>
+            <a:ext cx="5088948" cy="3820975"/>
           </a:xfrm>
           <a:prstGeom prst="rect">
             <a:avLst/>
@@ -10869,93 +11120,7 @@
             <a:noFill/>
           </a:ln>
         </p:spPr>
-        <p:txBody>
-          <a:bodyPr anchorCtr="0" anchor="t" bIns="91425" lIns="91425" spcFirstLastPara="1" rIns="91425" wrap="square" tIns="91425">
-            <a:spAutoFit/>
-          </a:bodyPr>
-          <a:lstStyle/>
-          <a:p>
-            <a:pPr indent="0" lvl="0" marL="0" marR="0" rtl="0" algn="l">
-              <a:lnSpc>
-                <a:spcPct val="100000"/>
-              </a:lnSpc>
-              <a:spcBef>
-                <a:spcPts val="0"/>
-              </a:spcBef>
-              <a:spcAft>
-                <a:spcPts val="0"/>
-              </a:spcAft>
-              <a:buClr>
-                <a:srgbClr val="000000"/>
-              </a:buClr>
-              <a:buSzPts val="2000"/>
-              <a:buFont typeface="Arial"/>
-              <a:buNone/>
-            </a:pPr>
-            <a:r>
-              <a:rPr b="0" i="0" lang="hu" sz="2000" u="none" cap="none" strike="noStrike">
-                <a:solidFill>
-                  <a:schemeClr val="dk2"/>
-                </a:solidFill>
-                <a:latin typeface="Arial"/>
-                <a:ea typeface="Arial"/>
-                <a:cs typeface="Arial"/>
-                <a:sym typeface="Arial"/>
-              </a:rPr>
-              <a:t>A WPF alkalmazás egy felhasználó kezelő program amely segítségével az “Adminisztrátor” kezelheti a felhasználóit: létrehozhat újat,törölhet,módosíthat.</a:t>
-            </a:r>
-            <a:endParaRPr b="0" i="0" sz="2000" u="none" cap="none" strike="noStrike">
-              <a:solidFill>
-                <a:schemeClr val="dk2"/>
-              </a:solidFill>
-              <a:latin typeface="Arial"/>
-              <a:ea typeface="Arial"/>
-              <a:cs typeface="Arial"/>
-              <a:sym typeface="Arial"/>
-            </a:endParaRPr>
-          </a:p>
-          <a:p>
-            <a:pPr indent="0" lvl="0" marL="0" marR="0" rtl="0" algn="l">
-              <a:lnSpc>
-                <a:spcPct val="100000"/>
-              </a:lnSpc>
-              <a:spcBef>
-                <a:spcPts val="0"/>
-              </a:spcBef>
-              <a:spcAft>
-                <a:spcPts val="0"/>
-              </a:spcAft>
-              <a:buClr>
-                <a:srgbClr val="000000"/>
-              </a:buClr>
-              <a:buSzPts val="2000"/>
-              <a:buFont typeface="Arial"/>
-              <a:buNone/>
-            </a:pPr>
-            <a:r>
-              <a:rPr b="0" i="0" lang="hu" sz="2000" u="none" cap="none" strike="noStrike">
-                <a:solidFill>
-                  <a:schemeClr val="dk2"/>
-                </a:solidFill>
-                <a:latin typeface="Arial"/>
-                <a:ea typeface="Arial"/>
-                <a:cs typeface="Arial"/>
-                <a:sym typeface="Arial"/>
-              </a:rPr>
-              <a:t>Csak be kell jelentkezni “Admin” felhasználóként és kész. Illetve be is lehet regisztrálni egy új felhasználót.</a:t>
-            </a:r>
-            <a:endParaRPr b="0" i="0" sz="2000" u="none" cap="none" strike="noStrike">
-              <a:solidFill>
-                <a:schemeClr val="dk2"/>
-              </a:solidFill>
-              <a:latin typeface="Arial"/>
-              <a:ea typeface="Arial"/>
-              <a:cs typeface="Arial"/>
-              <a:sym typeface="Arial"/>
-            </a:endParaRPr>
-          </a:p>
-        </p:txBody>
-      </p:sp>
+      </p:pic>
     </p:spTree>
   </p:cSld>
   <p:clrMapOvr>
@@ -11023,7 +11188,7 @@
             </a:pPr>
             <a:r>
               <a:rPr lang="hu"/>
-              <a:t>WPF Alkalmazás kinézete:</a:t>
+              <a:t>Ételfutár Weboldal jelenlegi állapota, kinézete:</a:t>
             </a:r>
             <a:endParaRPr/>
           </a:p>
@@ -11035,18 +11200,17 @@
           <p:cNvPicPr preferRelativeResize="0"/>
           <p:nvPr/>
         </p:nvPicPr>
-        <p:blipFill>
+        <p:blipFill rotWithShape="1">
           <a:blip r:embed="rId3">
             <a:alphaModFix/>
           </a:blip>
-          <a:stretch>
-            <a:fillRect/>
-          </a:stretch>
+          <a:srcRect b="0" l="0" r="0" t="0"/>
+          <a:stretch/>
         </p:blipFill>
         <p:spPr>
           <a:xfrm>
             <a:off x="152400" y="1170125"/>
-            <a:ext cx="6797460" cy="3820976"/>
+            <a:ext cx="8079595" cy="3820975"/>
           </a:xfrm>
           <a:prstGeom prst="rect">
             <a:avLst/>
@@ -11124,30 +11288,22 @@
             </a:pPr>
             <a:r>
               <a:rPr lang="hu"/>
-              <a:t>WPF Alkalmazás kinézete:</a:t>
+              <a:t>Adminisztrációs felület-WPF Alkalmazás:</a:t>
             </a:r>
             <a:endParaRPr/>
           </a:p>
         </p:txBody>
       </p:sp>
-      <p:pic>
-        <p:nvPicPr>
+      <p:sp>
+        <p:nvSpPr>
           <p:cNvPr id="140" name="Google Shape;140;p27"/>
-          <p:cNvPicPr preferRelativeResize="0"/>
+          <p:cNvSpPr txBox="1"/>
           <p:nvPr/>
-        </p:nvPicPr>
-        <p:blipFill>
-          <a:blip r:embed="rId3">
-            <a:alphaModFix/>
-          </a:blip>
-          <a:stretch>
-            <a:fillRect/>
-          </a:stretch>
-        </p:blipFill>
+        </p:nvSpPr>
         <p:spPr>
           <a:xfrm>
-            <a:off x="152400" y="1170125"/>
-            <a:ext cx="4000500" cy="3448050"/>
+            <a:off x="311700" y="1017725"/>
+            <a:ext cx="8335500" cy="2339700"/>
           </a:xfrm>
           <a:prstGeom prst="rect">
             <a:avLst/>
@@ -11157,35 +11313,125 @@
             <a:noFill/>
           </a:ln>
         </p:spPr>
-      </p:pic>
-      <p:pic>
-        <p:nvPicPr>
-          <p:cNvPr id="141" name="Google Shape;141;p27"/>
-          <p:cNvPicPr preferRelativeResize="0"/>
-          <p:nvPr/>
-        </p:nvPicPr>
-        <p:blipFill>
-          <a:blip r:embed="rId4">
-            <a:alphaModFix/>
-          </a:blip>
-          <a:stretch>
-            <a:fillRect/>
-          </a:stretch>
-        </p:blipFill>
-        <p:spPr>
-          <a:xfrm>
-            <a:off x="4305300" y="1170125"/>
-            <a:ext cx="3203213" cy="3820975"/>
-          </a:xfrm>
-          <a:prstGeom prst="rect">
-            <a:avLst/>
-          </a:prstGeom>
-          <a:noFill/>
-          <a:ln>
-            <a:noFill/>
-          </a:ln>
-        </p:spPr>
-      </p:pic>
+        <p:txBody>
+          <a:bodyPr anchorCtr="0" anchor="t" bIns="91425" lIns="91425" spcFirstLastPara="1" rIns="91425" wrap="square" tIns="91425">
+            <a:spAutoFit/>
+          </a:bodyPr>
+          <a:lstStyle/>
+          <a:p>
+            <a:pPr indent="0" lvl="0" marL="0" marR="0" rtl="0" algn="l">
+              <a:lnSpc>
+                <a:spcPct val="100000"/>
+              </a:lnSpc>
+              <a:spcBef>
+                <a:spcPts val="0"/>
+              </a:spcBef>
+              <a:spcAft>
+                <a:spcPts val="0"/>
+              </a:spcAft>
+              <a:buClr>
+                <a:srgbClr val="000000"/>
+              </a:buClr>
+              <a:buSzPts val="2000"/>
+              <a:buFont typeface="Arial"/>
+              <a:buNone/>
+            </a:pPr>
+            <a:r>
+              <a:rPr b="0" i="0" lang="hu" sz="2000" u="none" cap="none" strike="noStrike">
+                <a:solidFill>
+                  <a:schemeClr val="dk2"/>
+                </a:solidFill>
+                <a:latin typeface="Arial"/>
+                <a:ea typeface="Arial"/>
+                <a:cs typeface="Arial"/>
+                <a:sym typeface="Arial"/>
+              </a:rPr>
+              <a:t>A WPF alkalmazás egy felhasználó kezelő program amely segítségével az “Adminisztrátor” kezelheti a felhasználóit: létrehozhat újat,törölhet,módosíthat.</a:t>
+            </a:r>
+            <a:endParaRPr b="0" i="0" sz="2000" u="none" cap="none" strike="noStrike">
+              <a:solidFill>
+                <a:schemeClr val="dk2"/>
+              </a:solidFill>
+              <a:latin typeface="Arial"/>
+              <a:ea typeface="Arial"/>
+              <a:cs typeface="Arial"/>
+              <a:sym typeface="Arial"/>
+            </a:endParaRPr>
+          </a:p>
+          <a:p>
+            <a:pPr indent="0" lvl="0" marL="0" marR="0" rtl="0" algn="l">
+              <a:lnSpc>
+                <a:spcPct val="100000"/>
+              </a:lnSpc>
+              <a:spcBef>
+                <a:spcPts val="0"/>
+              </a:spcBef>
+              <a:spcAft>
+                <a:spcPts val="0"/>
+              </a:spcAft>
+              <a:buClr>
+                <a:srgbClr val="000000"/>
+              </a:buClr>
+              <a:buSzPts val="2000"/>
+              <a:buFont typeface="Arial"/>
+              <a:buNone/>
+            </a:pPr>
+            <a:r>
+              <a:rPr b="0" i="0" lang="hu" sz="2000" u="none" cap="none" strike="noStrike">
+                <a:solidFill>
+                  <a:schemeClr val="dk2"/>
+                </a:solidFill>
+                <a:latin typeface="Arial"/>
+                <a:ea typeface="Arial"/>
+                <a:cs typeface="Arial"/>
+                <a:sym typeface="Arial"/>
+              </a:rPr>
+              <a:t>Csak be kell jelentkezni “Admin” felhasználóként és kész. Illetve be is lehet regisztrálni egy új felhasználót.</a:t>
+            </a:r>
+            <a:endParaRPr b="0" i="0" sz="2000" u="none" cap="none" strike="noStrike">
+              <a:solidFill>
+                <a:schemeClr val="dk2"/>
+              </a:solidFill>
+              <a:latin typeface="Arial"/>
+              <a:ea typeface="Arial"/>
+              <a:cs typeface="Arial"/>
+              <a:sym typeface="Arial"/>
+            </a:endParaRPr>
+          </a:p>
+          <a:p>
+            <a:pPr indent="0" lvl="0" marL="0" marR="0" rtl="0" algn="l">
+              <a:lnSpc>
+                <a:spcPct val="100000"/>
+              </a:lnSpc>
+              <a:spcBef>
+                <a:spcPts val="0"/>
+              </a:spcBef>
+              <a:spcAft>
+                <a:spcPts val="0"/>
+              </a:spcAft>
+              <a:buClr>
+                <a:srgbClr val="000000"/>
+              </a:buClr>
+              <a:buSzPts val="2000"/>
+              <a:buFont typeface="Arial"/>
+              <a:buNone/>
+            </a:pPr>
+            <a:r>
+              <a:rPr lang="hu" sz="2000">
+                <a:solidFill>
+                  <a:schemeClr val="dk2"/>
+                </a:solidFill>
+              </a:rPr>
+              <a:t>Valamint nem csak felhasználót kezelhet hanem az összes tábláját az adatbázisnak.</a:t>
+            </a:r>
+            <a:endParaRPr sz="2000">
+              <a:solidFill>
+                <a:schemeClr val="dk2"/>
+              </a:solidFill>
+            </a:endParaRPr>
+          </a:p>
+        </p:txBody>
+      </p:sp>
     </p:spTree>
   </p:cSld>
   <p:clrMapOvr>
@@ -11199,7 +11445,7 @@
   <p:cSld>
     <p:spTree>
       <p:nvGrpSpPr>
-        <p:cNvPr id="145" name="Shape 145"/>
+        <p:cNvPr id="144" name="Shape 144"/>
         <p:cNvGrpSpPr/>
         <p:nvPr/>
       </p:nvGrpSpPr>
@@ -11213,7 +11459,7 @@
       </p:grpSpPr>
       <p:sp>
         <p:nvSpPr>
-          <p:cNvPr id="146" name="Google Shape;146;p28"/>
+          <p:cNvPr id="145" name="Google Shape;145;p28"/>
           <p:cNvSpPr txBox="1"/>
           <p:nvPr>
             <p:ph type="title"/>
@@ -11261,17 +11507,243 @@
       </p:sp>
       <p:pic>
         <p:nvPicPr>
-          <p:cNvPr id="147" name="Google Shape;147;p28"/>
+          <p:cNvPr id="146" name="Google Shape;146;p28"/>
           <p:cNvPicPr preferRelativeResize="0"/>
           <p:nvPr/>
         </p:nvPicPr>
-        <p:blipFill>
+        <p:blipFill rotWithShape="1">
           <a:blip r:embed="rId3">
             <a:alphaModFix/>
           </a:blip>
-          <a:stretch>
-            <a:fillRect/>
-          </a:stretch>
+          <a:srcRect b="0" l="0" r="0" t="0"/>
+          <a:stretch/>
+        </p:blipFill>
+        <p:spPr>
+          <a:xfrm>
+            <a:off x="152400" y="1170125"/>
+            <a:ext cx="6797460" cy="3820976"/>
+          </a:xfrm>
+          <a:prstGeom prst="rect">
+            <a:avLst/>
+          </a:prstGeom>
+          <a:noFill/>
+          <a:ln>
+            <a:noFill/>
+          </a:ln>
+        </p:spPr>
+      </p:pic>
+    </p:spTree>
+  </p:cSld>
+  <p:clrMapOvr>
+    <a:masterClrMapping/>
+  </p:clrMapOvr>
+</p:sld>
+</file>
+
+<file path=ppt/slides/slide17.xml><?xml version="1.0" encoding="utf-8"?>
+<p:sld xmlns:a="http://schemas.openxmlformats.org/drawingml/2006/main" xmlns:r="http://schemas.openxmlformats.org/officeDocument/2006/relationships" xmlns:mc="http://schemas.openxmlformats.org/markup-compatibility/2006" xmlns:mv="urn:schemas-microsoft-com:mac:vml" xmlns:p="http://schemas.openxmlformats.org/presentationml/2006/main" xmlns:c="http://schemas.openxmlformats.org/drawingml/2006/chart" xmlns:dgm="http://schemas.openxmlformats.org/drawingml/2006/diagram" xmlns:o="urn:schemas-microsoft-com:office:office" xmlns:v="urn:schemas-microsoft-com:vml" xmlns:pvml="urn:schemas-microsoft-com:office:powerpoint" xmlns:com="http://schemas.openxmlformats.org/drawingml/2006/compatibility" xmlns:p14="http://schemas.microsoft.com/office/powerpoint/2010/main" xmlns:p15="http://schemas.microsoft.com/office/powerpoint/2012/main" xmlns:ahyp="http://schemas.microsoft.com/office/drawing/2018/hyperlinkcolor">
+  <p:cSld>
+    <p:spTree>
+      <p:nvGrpSpPr>
+        <p:cNvPr id="150" name="Shape 150"/>
+        <p:cNvGrpSpPr/>
+        <p:nvPr/>
+      </p:nvGrpSpPr>
+      <p:grpSpPr>
+        <a:xfrm>
+          <a:off x="0" y="0"/>
+          <a:ext cx="0" cy="0"/>
+          <a:chOff x="0" y="0"/>
+          <a:chExt cx="0" cy="0"/>
+        </a:xfrm>
+      </p:grpSpPr>
+      <p:sp>
+        <p:nvSpPr>
+          <p:cNvPr id="151" name="Google Shape;151;p29"/>
+          <p:cNvSpPr txBox="1"/>
+          <p:nvPr>
+            <p:ph type="title"/>
+          </p:nvPr>
+        </p:nvSpPr>
+        <p:spPr>
+          <a:xfrm>
+            <a:off x="311700" y="445025"/>
+            <a:ext cx="8520600" cy="572700"/>
+          </a:xfrm>
+          <a:prstGeom prst="rect">
+            <a:avLst/>
+          </a:prstGeom>
+          <a:noFill/>
+          <a:ln>
+            <a:noFill/>
+          </a:ln>
+        </p:spPr>
+        <p:txBody>
+          <a:bodyPr anchorCtr="0" anchor="t" bIns="91425" lIns="91425" spcFirstLastPara="1" rIns="91425" wrap="square" tIns="91425">
+            <a:normAutofit fontScale="90000"/>
+          </a:bodyPr>
+          <a:lstStyle/>
+          <a:p>
+            <a:pPr indent="0" lvl="0" marL="0" rtl="0" algn="l">
+              <a:lnSpc>
+                <a:spcPct val="100000"/>
+              </a:lnSpc>
+              <a:spcBef>
+                <a:spcPts val="0"/>
+              </a:spcBef>
+              <a:spcAft>
+                <a:spcPts val="0"/>
+              </a:spcAft>
+              <a:buSzPct val="111111"/>
+              <a:buNone/>
+            </a:pPr>
+            <a:r>
+              <a:rPr lang="hu"/>
+              <a:t>WPF Alkalmazás kinézete:</a:t>
+            </a:r>
+            <a:endParaRPr/>
+          </a:p>
+        </p:txBody>
+      </p:sp>
+      <p:pic>
+        <p:nvPicPr>
+          <p:cNvPr id="152" name="Google Shape;152;p29"/>
+          <p:cNvPicPr preferRelativeResize="0"/>
+          <p:nvPr/>
+        </p:nvPicPr>
+        <p:blipFill rotWithShape="1">
+          <a:blip r:embed="rId3">
+            <a:alphaModFix/>
+          </a:blip>
+          <a:srcRect b="0" l="0" r="0" t="0"/>
+          <a:stretch/>
+        </p:blipFill>
+        <p:spPr>
+          <a:xfrm>
+            <a:off x="152400" y="1170125"/>
+            <a:ext cx="4000500" cy="3448050"/>
+          </a:xfrm>
+          <a:prstGeom prst="rect">
+            <a:avLst/>
+          </a:prstGeom>
+          <a:noFill/>
+          <a:ln>
+            <a:noFill/>
+          </a:ln>
+        </p:spPr>
+      </p:pic>
+      <p:pic>
+        <p:nvPicPr>
+          <p:cNvPr id="153" name="Google Shape;153;p29"/>
+          <p:cNvPicPr preferRelativeResize="0"/>
+          <p:nvPr/>
+        </p:nvPicPr>
+        <p:blipFill rotWithShape="1">
+          <a:blip r:embed="rId4">
+            <a:alphaModFix/>
+          </a:blip>
+          <a:srcRect b="0" l="0" r="0" t="0"/>
+          <a:stretch/>
+        </p:blipFill>
+        <p:spPr>
+          <a:xfrm>
+            <a:off x="4305300" y="1170125"/>
+            <a:ext cx="3203213" cy="3820975"/>
+          </a:xfrm>
+          <a:prstGeom prst="rect">
+            <a:avLst/>
+          </a:prstGeom>
+          <a:noFill/>
+          <a:ln>
+            <a:noFill/>
+          </a:ln>
+        </p:spPr>
+      </p:pic>
+    </p:spTree>
+  </p:cSld>
+  <p:clrMapOvr>
+    <a:masterClrMapping/>
+  </p:clrMapOvr>
+</p:sld>
+</file>
+
+<file path=ppt/slides/slide18.xml><?xml version="1.0" encoding="utf-8"?>
+<p:sld xmlns:a="http://schemas.openxmlformats.org/drawingml/2006/main" xmlns:r="http://schemas.openxmlformats.org/officeDocument/2006/relationships" xmlns:mc="http://schemas.openxmlformats.org/markup-compatibility/2006" xmlns:mv="urn:schemas-microsoft-com:mac:vml" xmlns:p="http://schemas.openxmlformats.org/presentationml/2006/main" xmlns:c="http://schemas.openxmlformats.org/drawingml/2006/chart" xmlns:dgm="http://schemas.openxmlformats.org/drawingml/2006/diagram" xmlns:o="urn:schemas-microsoft-com:office:office" xmlns:v="urn:schemas-microsoft-com:vml" xmlns:pvml="urn:schemas-microsoft-com:office:powerpoint" xmlns:com="http://schemas.openxmlformats.org/drawingml/2006/compatibility" xmlns:p14="http://schemas.microsoft.com/office/powerpoint/2010/main" xmlns:p15="http://schemas.microsoft.com/office/powerpoint/2012/main" xmlns:ahyp="http://schemas.microsoft.com/office/drawing/2018/hyperlinkcolor">
+  <p:cSld>
+    <p:spTree>
+      <p:nvGrpSpPr>
+        <p:cNvPr id="157" name="Shape 157"/>
+        <p:cNvGrpSpPr/>
+        <p:nvPr/>
+      </p:nvGrpSpPr>
+      <p:grpSpPr>
+        <a:xfrm>
+          <a:off x="0" y="0"/>
+          <a:ext cx="0" cy="0"/>
+          <a:chOff x="0" y="0"/>
+          <a:chExt cx="0" cy="0"/>
+        </a:xfrm>
+      </p:grpSpPr>
+      <p:sp>
+        <p:nvSpPr>
+          <p:cNvPr id="158" name="Google Shape;158;p30"/>
+          <p:cNvSpPr txBox="1"/>
+          <p:nvPr>
+            <p:ph type="title"/>
+          </p:nvPr>
+        </p:nvSpPr>
+        <p:spPr>
+          <a:xfrm>
+            <a:off x="311700" y="445025"/>
+            <a:ext cx="8520600" cy="572700"/>
+          </a:xfrm>
+          <a:prstGeom prst="rect">
+            <a:avLst/>
+          </a:prstGeom>
+          <a:noFill/>
+          <a:ln>
+            <a:noFill/>
+          </a:ln>
+        </p:spPr>
+        <p:txBody>
+          <a:bodyPr anchorCtr="0" anchor="t" bIns="91425" lIns="91425" spcFirstLastPara="1" rIns="91425" wrap="square" tIns="91425">
+            <a:normAutofit fontScale="90000"/>
+          </a:bodyPr>
+          <a:lstStyle/>
+          <a:p>
+            <a:pPr indent="0" lvl="0" marL="0" rtl="0" algn="l">
+              <a:lnSpc>
+                <a:spcPct val="100000"/>
+              </a:lnSpc>
+              <a:spcBef>
+                <a:spcPts val="0"/>
+              </a:spcBef>
+              <a:spcAft>
+                <a:spcPts val="0"/>
+              </a:spcAft>
+              <a:buSzPct val="111111"/>
+              <a:buNone/>
+            </a:pPr>
+            <a:r>
+              <a:rPr lang="hu"/>
+              <a:t>WPF Alkalmazás kinézete:</a:t>
+            </a:r>
+            <a:endParaRPr/>
+          </a:p>
+        </p:txBody>
+      </p:sp>
+      <p:pic>
+        <p:nvPicPr>
+          <p:cNvPr id="159" name="Google Shape;159;p30"/>
+          <p:cNvPicPr preferRelativeResize="0"/>
+          <p:nvPr/>
+        </p:nvPicPr>
+        <p:blipFill rotWithShape="1">
+          <a:blip r:embed="rId3">
+            <a:alphaModFix/>
+          </a:blip>
+          <a:srcRect b="0" l="0" r="0" t="0"/>
+          <a:stretch/>
         </p:blipFill>
         <p:spPr>
           <a:xfrm>
@@ -11354,7 +11826,7 @@
             </a:pPr>
             <a:r>
               <a:rPr lang="hu"/>
-              <a:t>Ételfutár Weboldal</a:t>
+              <a:t>Ételfutár Weboldal Témája</a:t>
             </a:r>
             <a:endParaRPr/>
           </a:p>
@@ -11387,7 +11859,7 @@
           </a:bodyPr>
           <a:lstStyle/>
           <a:p>
-            <a:pPr indent="0" lvl="0" marL="0" rtl="0" algn="ctr">
+            <a:pPr indent="0" lvl="0" marL="0" rtl="0" algn="l">
               <a:lnSpc>
                 <a:spcPct val="115000"/>
               </a:lnSpc>
@@ -11395,14 +11867,54 @@
                 <a:spcPts val="0"/>
               </a:spcBef>
               <a:spcAft>
-                <a:spcPts val="1200"/>
+                <a:spcPts val="0"/>
               </a:spcAft>
               <a:buSzPts val="1800"/>
               <a:buNone/>
             </a:pPr>
             <a:r>
               <a:rPr lang="hu" sz="2000"/>
-              <a:t>Mi vagyunk az Ételfutár. Üdvözöljük weblapunkon ahol kényelmesen rendelhet ételeket Miskolci éttermekből vagy akár egyéb városok éttermeiből. Cégünk étel rendeléssel és kiszállítással foglalkozik. Csak regisztráljon és már rendelhet is ételt házhoz azonnal. Kényelmesen, rugalmasan rendelhet friss ételt tőlünk.</a:t>
+              <a:t>Ételrendeléssel foglalkozó weboldal amelyen keresztül rendelhet a felhasználó ételeket kiváló minőségben és áron.</a:t>
+            </a:r>
+            <a:endParaRPr sz="2000"/>
+          </a:p>
+          <a:p>
+            <a:pPr indent="0" lvl="0" marL="0" rtl="0" algn="l">
+              <a:lnSpc>
+                <a:spcPct val="115000"/>
+              </a:lnSpc>
+              <a:spcBef>
+                <a:spcPts val="1200"/>
+              </a:spcBef>
+              <a:spcAft>
+                <a:spcPts val="0"/>
+              </a:spcAft>
+              <a:buSzPts val="1800"/>
+              <a:buNone/>
+            </a:pPr>
+            <a:r>
+              <a:rPr lang="hu" sz="2000"/>
+              <a:t>Ételek közül lehet válogatni és fel is lehet adni rendelést.</a:t>
+            </a:r>
+            <a:endParaRPr sz="2000"/>
+          </a:p>
+          <a:p>
+            <a:pPr indent="0" lvl="0" marL="0" rtl="0" algn="l">
+              <a:lnSpc>
+                <a:spcPct val="115000"/>
+              </a:lnSpc>
+              <a:spcBef>
+                <a:spcPts val="1200"/>
+              </a:spcBef>
+              <a:spcAft>
+                <a:spcPts val="1200"/>
+              </a:spcAft>
+              <a:buSzPts val="1800"/>
+              <a:buNone/>
+            </a:pPr>
+            <a:r>
+              <a:rPr lang="hu" sz="2000"/>
+              <a:t>Az adatbázisunk segítségével eltároljuk az ételeket amelyek közül választani lehet, illetve eltároljuk a leadott rendeléseket amelyeket leadhat egy felhasználó.</a:t>
             </a:r>
             <a:endParaRPr sz="2000"/>
           </a:p>
@@ -11766,7 +12278,7 @@
         </p:spPr>
         <p:txBody>
           <a:bodyPr anchorCtr="0" anchor="t" bIns="91425" lIns="91425" spcFirstLastPara="1" rIns="91425" wrap="square" tIns="91425">
-            <a:normAutofit lnSpcReduction="20000"/>
+            <a:normAutofit fontScale="85000" lnSpcReduction="20000"/>
           </a:bodyPr>
           <a:lstStyle/>
           <a:p>
@@ -11780,7 +12292,7 @@
               <a:spcAft>
                 <a:spcPts val="0"/>
               </a:spcAft>
-              <a:buSzPts val="1800"/>
+              <a:buSzPct val="100000"/>
               <a:buNone/>
             </a:pPr>
             <a:r>
@@ -11800,12 +12312,12 @@
               <a:spcAft>
                 <a:spcPts val="0"/>
               </a:spcAft>
-              <a:buSzPts val="1800"/>
+              <a:buSzPct val="100000"/>
               <a:buNone/>
             </a:pPr>
             <a:r>
               <a:rPr lang="hu"/>
-              <a:t>A “backend” a következő képpen működik. Van rengeteg végpont amely az oldal működéséért felelősek. Például a keresőnek kell a lekérdezéshez egy “backend”-es végpont amely lekérdezi az ételeket és ad rá találatokat.</a:t>
+              <a:t>A “backend” a következő képpen működik. “Entity Framework” segítségével működik. Van rengeteg végpont amely az oldal működéséért felelősek. Például a keresőnek kell a lekérdezéshez egy “backend”-es végpont amely lekérdezi az ételeket és ad rá találatokat.</a:t>
             </a:r>
             <a:endParaRPr/>
           </a:p>
@@ -11820,12 +12332,12 @@
               <a:spcAft>
                 <a:spcPts val="0"/>
               </a:spcAft>
-              <a:buSzPts val="1800"/>
+              <a:buSzPct val="100000"/>
               <a:buNone/>
             </a:pPr>
             <a:r>
               <a:rPr lang="hu"/>
-              <a:t>A backend-ben “Scaffold konzolos parancs”-al legeneráltunk osztályokat amelyeket a Controllerek-ben használunk fel a végpontoknál.</a:t>
+              <a:t>A backend-ben “Scaffold konzolos parancs”-al legeneráltunk osztályokat amelyeket a Controllerek-ben használunk fel a végpontoknál. Illetve ha szükséges volt csináltunk DTO-kat is hozzá.</a:t>
             </a:r>
             <a:endParaRPr/>
           </a:p>
@@ -11840,7 +12352,7 @@
               <a:spcAft>
                 <a:spcPts val="0"/>
               </a:spcAft>
-              <a:buSzPts val="1800"/>
+              <a:buSzPct val="100000"/>
               <a:buNone/>
             </a:pPr>
             <a:r>
@@ -11860,7 +12372,7 @@
               <a:spcAft>
                 <a:spcPts val="0"/>
               </a:spcAft>
-              <a:buSzPts val="1800"/>
+              <a:buSzPct val="100000"/>
               <a:buNone/>
             </a:pPr>
             <a:r>
@@ -11879,7 +12391,7 @@
               <a:spcAft>
                 <a:spcPts val="1200"/>
               </a:spcAft>
-              <a:buSzPts val="1800"/>
+              <a:buSzPct val="100000"/>
               <a:buNone/>
             </a:pPr>
             <a:r>
@@ -11956,6 +12468,208 @@
             </a:pPr>
             <a:r>
               <a:rPr lang="hu"/>
+              <a:t>Backend Működése: UML ábra az útvonalakról</a:t>
+            </a:r>
+            <a:endParaRPr/>
+          </a:p>
+        </p:txBody>
+      </p:sp>
+      <p:pic>
+        <p:nvPicPr>
+          <p:cNvPr id="85" name="Google Shape;85;p18"/>
+          <p:cNvPicPr preferRelativeResize="0"/>
+          <p:nvPr/>
+        </p:nvPicPr>
+        <p:blipFill>
+          <a:blip r:embed="rId3">
+            <a:alphaModFix/>
+          </a:blip>
+          <a:stretch>
+            <a:fillRect/>
+          </a:stretch>
+        </p:blipFill>
+        <p:spPr>
+          <a:xfrm>
+            <a:off x="152400" y="1170125"/>
+            <a:ext cx="4371825" cy="3820975"/>
+          </a:xfrm>
+          <a:prstGeom prst="rect">
+            <a:avLst/>
+          </a:prstGeom>
+          <a:noFill/>
+          <a:ln>
+            <a:noFill/>
+          </a:ln>
+        </p:spPr>
+      </p:pic>
+    </p:spTree>
+  </p:cSld>
+  <p:clrMapOvr>
+    <a:masterClrMapping/>
+  </p:clrMapOvr>
+</p:sld>
+</file>
+
+<file path=ppt/slides/slide7.xml><?xml version="1.0" encoding="utf-8"?>
+<p:sld xmlns:a="http://schemas.openxmlformats.org/drawingml/2006/main" xmlns:r="http://schemas.openxmlformats.org/officeDocument/2006/relationships" xmlns:mc="http://schemas.openxmlformats.org/markup-compatibility/2006" xmlns:mv="urn:schemas-microsoft-com:mac:vml" xmlns:p="http://schemas.openxmlformats.org/presentationml/2006/main" xmlns:c="http://schemas.openxmlformats.org/drawingml/2006/chart" xmlns:dgm="http://schemas.openxmlformats.org/drawingml/2006/diagram" xmlns:o="urn:schemas-microsoft-com:office:office" xmlns:v="urn:schemas-microsoft-com:vml" xmlns:pvml="urn:schemas-microsoft-com:office:powerpoint" xmlns:com="http://schemas.openxmlformats.org/drawingml/2006/compatibility" xmlns:p14="http://schemas.microsoft.com/office/powerpoint/2010/main" xmlns:p15="http://schemas.microsoft.com/office/powerpoint/2012/main" xmlns:ahyp="http://schemas.microsoft.com/office/drawing/2018/hyperlinkcolor">
+  <p:cSld>
+    <p:spTree>
+      <p:nvGrpSpPr>
+        <p:cNvPr id="89" name="Shape 89"/>
+        <p:cNvGrpSpPr/>
+        <p:nvPr/>
+      </p:nvGrpSpPr>
+      <p:grpSpPr>
+        <a:xfrm>
+          <a:off x="0" y="0"/>
+          <a:ext cx="0" cy="0"/>
+          <a:chOff x="0" y="0"/>
+          <a:chExt cx="0" cy="0"/>
+        </a:xfrm>
+      </p:grpSpPr>
+      <p:sp>
+        <p:nvSpPr>
+          <p:cNvPr id="90" name="Google Shape;90;p19"/>
+          <p:cNvSpPr txBox="1"/>
+          <p:nvPr>
+            <p:ph type="title"/>
+          </p:nvPr>
+        </p:nvSpPr>
+        <p:spPr>
+          <a:xfrm>
+            <a:off x="311700" y="445025"/>
+            <a:ext cx="8520600" cy="572700"/>
+          </a:xfrm>
+          <a:prstGeom prst="rect">
+            <a:avLst/>
+          </a:prstGeom>
+          <a:noFill/>
+          <a:ln>
+            <a:noFill/>
+          </a:ln>
+        </p:spPr>
+        <p:txBody>
+          <a:bodyPr anchorCtr="0" anchor="t" bIns="91425" lIns="91425" spcFirstLastPara="1" rIns="91425" wrap="square" tIns="91425">
+            <a:normAutofit fontScale="90000"/>
+          </a:bodyPr>
+          <a:lstStyle/>
+          <a:p>
+            <a:pPr indent="0" lvl="0" marL="0" rtl="0" algn="l">
+              <a:lnSpc>
+                <a:spcPct val="100000"/>
+              </a:lnSpc>
+              <a:spcBef>
+                <a:spcPts val="0"/>
+              </a:spcBef>
+              <a:spcAft>
+                <a:spcPts val="0"/>
+              </a:spcAft>
+              <a:buSzPct val="111111"/>
+              <a:buNone/>
+            </a:pPr>
+            <a:r>
+              <a:rPr lang="hu"/>
+              <a:t>Backend Működése: A végpontok tesztelése Swagger UI-val történik</a:t>
+            </a:r>
+            <a:endParaRPr/>
+          </a:p>
+        </p:txBody>
+      </p:sp>
+      <p:pic>
+        <p:nvPicPr>
+          <p:cNvPr id="91" name="Google Shape;91;p19"/>
+          <p:cNvPicPr preferRelativeResize="0"/>
+          <p:nvPr/>
+        </p:nvPicPr>
+        <p:blipFill>
+          <a:blip r:embed="rId3">
+            <a:alphaModFix/>
+          </a:blip>
+          <a:stretch>
+            <a:fillRect/>
+          </a:stretch>
+        </p:blipFill>
+        <p:spPr>
+          <a:xfrm>
+            <a:off x="152400" y="1334500"/>
+            <a:ext cx="7690077" cy="3656600"/>
+          </a:xfrm>
+          <a:prstGeom prst="rect">
+            <a:avLst/>
+          </a:prstGeom>
+          <a:noFill/>
+          <a:ln>
+            <a:noFill/>
+          </a:ln>
+        </p:spPr>
+      </p:pic>
+    </p:spTree>
+  </p:cSld>
+  <p:clrMapOvr>
+    <a:masterClrMapping/>
+  </p:clrMapOvr>
+</p:sld>
+</file>
+
+<file path=ppt/slides/slide8.xml><?xml version="1.0" encoding="utf-8"?>
+<p:sld xmlns:a="http://schemas.openxmlformats.org/drawingml/2006/main" xmlns:r="http://schemas.openxmlformats.org/officeDocument/2006/relationships" xmlns:mc="http://schemas.openxmlformats.org/markup-compatibility/2006" xmlns:mv="urn:schemas-microsoft-com:mac:vml" xmlns:p="http://schemas.openxmlformats.org/presentationml/2006/main" xmlns:c="http://schemas.openxmlformats.org/drawingml/2006/chart" xmlns:dgm="http://schemas.openxmlformats.org/drawingml/2006/diagram" xmlns:o="urn:schemas-microsoft-com:office:office" xmlns:v="urn:schemas-microsoft-com:vml" xmlns:pvml="urn:schemas-microsoft-com:office:powerpoint" xmlns:com="http://schemas.openxmlformats.org/drawingml/2006/compatibility" xmlns:p14="http://schemas.microsoft.com/office/powerpoint/2010/main" xmlns:p15="http://schemas.microsoft.com/office/powerpoint/2012/main" xmlns:ahyp="http://schemas.microsoft.com/office/drawing/2018/hyperlinkcolor">
+  <p:cSld>
+    <p:spTree>
+      <p:nvGrpSpPr>
+        <p:cNvPr id="95" name="Shape 95"/>
+        <p:cNvGrpSpPr/>
+        <p:nvPr/>
+      </p:nvGrpSpPr>
+      <p:grpSpPr>
+        <a:xfrm>
+          <a:off x="0" y="0"/>
+          <a:ext cx="0" cy="0"/>
+          <a:chOff x="0" y="0"/>
+          <a:chExt cx="0" cy="0"/>
+        </a:xfrm>
+      </p:grpSpPr>
+      <p:sp>
+        <p:nvSpPr>
+          <p:cNvPr id="96" name="Google Shape;96;p20"/>
+          <p:cNvSpPr txBox="1"/>
+          <p:nvPr>
+            <p:ph type="title"/>
+          </p:nvPr>
+        </p:nvSpPr>
+        <p:spPr>
+          <a:xfrm>
+            <a:off x="311700" y="445025"/>
+            <a:ext cx="8520600" cy="572700"/>
+          </a:xfrm>
+          <a:prstGeom prst="rect">
+            <a:avLst/>
+          </a:prstGeom>
+          <a:noFill/>
+          <a:ln>
+            <a:noFill/>
+          </a:ln>
+        </p:spPr>
+        <p:txBody>
+          <a:bodyPr anchorCtr="0" anchor="t" bIns="91425" lIns="91425" spcFirstLastPara="1" rIns="91425" wrap="square" tIns="91425">
+            <a:normAutofit fontScale="90000"/>
+          </a:bodyPr>
+          <a:lstStyle/>
+          <a:p>
+            <a:pPr indent="0" lvl="0" marL="0" rtl="0" algn="l">
+              <a:lnSpc>
+                <a:spcPct val="100000"/>
+              </a:lnSpc>
+              <a:spcBef>
+                <a:spcPts val="0"/>
+              </a:spcBef>
+              <a:spcAft>
+                <a:spcPts val="0"/>
+              </a:spcAft>
+              <a:buSzPct val="111111"/>
+              <a:buNone/>
+            </a:pPr>
+            <a:r>
+              <a:rPr lang="hu"/>
               <a:t>Adatbázis Működése</a:t>
             </a:r>
             <a:endParaRPr/>
@@ -11964,7 +12678,7 @@
       </p:sp>
       <p:sp>
         <p:nvSpPr>
-          <p:cNvPr id="85" name="Google Shape;85;p18"/>
+          <p:cNvPr id="97" name="Google Shape;97;p20"/>
           <p:cNvSpPr txBox="1"/>
           <p:nvPr>
             <p:ph idx="1" type="body"/>
@@ -12031,7 +12745,7 @@
       </p:sp>
       <p:pic>
         <p:nvPicPr>
-          <p:cNvPr id="86" name="Google Shape;86;p18"/>
+          <p:cNvPr id="98" name="Google Shape;98;p20"/>
           <p:cNvPicPr preferRelativeResize="0"/>
           <p:nvPr/>
         </p:nvPicPr>
@@ -12046,210 +12760,6 @@
           <a:xfrm>
             <a:off x="1605700" y="2006100"/>
             <a:ext cx="5084100" cy="2985174"/>
-          </a:xfrm>
-          <a:prstGeom prst="rect">
-            <a:avLst/>
-          </a:prstGeom>
-          <a:noFill/>
-          <a:ln>
-            <a:noFill/>
-          </a:ln>
-        </p:spPr>
-      </p:pic>
-    </p:spTree>
-  </p:cSld>
-  <p:clrMapOvr>
-    <a:masterClrMapping/>
-  </p:clrMapOvr>
-</p:sld>
-</file>
-
-<file path=ppt/slides/slide7.xml><?xml version="1.0" encoding="utf-8"?>
-<p:sld xmlns:a="http://schemas.openxmlformats.org/drawingml/2006/main" xmlns:r="http://schemas.openxmlformats.org/officeDocument/2006/relationships" xmlns:mc="http://schemas.openxmlformats.org/markup-compatibility/2006" xmlns:mv="urn:schemas-microsoft-com:mac:vml" xmlns:p="http://schemas.openxmlformats.org/presentationml/2006/main" xmlns:c="http://schemas.openxmlformats.org/drawingml/2006/chart" xmlns:dgm="http://schemas.openxmlformats.org/drawingml/2006/diagram" xmlns:o="urn:schemas-microsoft-com:office:office" xmlns:v="urn:schemas-microsoft-com:vml" xmlns:pvml="urn:schemas-microsoft-com:office:powerpoint" xmlns:com="http://schemas.openxmlformats.org/drawingml/2006/compatibility" xmlns:p14="http://schemas.microsoft.com/office/powerpoint/2010/main" xmlns:p15="http://schemas.microsoft.com/office/powerpoint/2012/main" xmlns:ahyp="http://schemas.microsoft.com/office/drawing/2018/hyperlinkcolor">
-  <p:cSld>
-    <p:spTree>
-      <p:nvGrpSpPr>
-        <p:cNvPr id="90" name="Shape 90"/>
-        <p:cNvGrpSpPr/>
-        <p:nvPr/>
-      </p:nvGrpSpPr>
-      <p:grpSpPr>
-        <a:xfrm>
-          <a:off x="0" y="0"/>
-          <a:ext cx="0" cy="0"/>
-          <a:chOff x="0" y="0"/>
-          <a:chExt cx="0" cy="0"/>
-        </a:xfrm>
-      </p:grpSpPr>
-      <p:sp>
-        <p:nvSpPr>
-          <p:cNvPr id="91" name="Google Shape;91;p19"/>
-          <p:cNvSpPr txBox="1"/>
-          <p:nvPr>
-            <p:ph type="title"/>
-          </p:nvPr>
-        </p:nvSpPr>
-        <p:spPr>
-          <a:xfrm>
-            <a:off x="311700" y="445025"/>
-            <a:ext cx="8520600" cy="572700"/>
-          </a:xfrm>
-          <a:prstGeom prst="rect">
-            <a:avLst/>
-          </a:prstGeom>
-          <a:noFill/>
-          <a:ln>
-            <a:noFill/>
-          </a:ln>
-        </p:spPr>
-        <p:txBody>
-          <a:bodyPr anchorCtr="0" anchor="t" bIns="91425" lIns="91425" spcFirstLastPara="1" rIns="91425" wrap="square" tIns="91425">
-            <a:normAutofit fontScale="90000"/>
-          </a:bodyPr>
-          <a:lstStyle/>
-          <a:p>
-            <a:pPr indent="0" lvl="0" marL="0" rtl="0" algn="l">
-              <a:lnSpc>
-                <a:spcPct val="100000"/>
-              </a:lnSpc>
-              <a:spcBef>
-                <a:spcPts val="0"/>
-              </a:spcBef>
-              <a:spcAft>
-                <a:spcPts val="0"/>
-              </a:spcAft>
-              <a:buSzPct val="111111"/>
-              <a:buNone/>
-            </a:pPr>
-            <a:r>
-              <a:rPr lang="hu"/>
-              <a:t>Ételfutár Weboldalnak a Főoldal Rácsszerkezete:</a:t>
-            </a:r>
-            <a:endParaRPr/>
-          </a:p>
-        </p:txBody>
-      </p:sp>
-      <p:pic>
-        <p:nvPicPr>
-          <p:cNvPr id="92" name="Google Shape;92;p19"/>
-          <p:cNvPicPr preferRelativeResize="0"/>
-          <p:nvPr/>
-        </p:nvPicPr>
-        <p:blipFill rotWithShape="1">
-          <a:blip r:embed="rId3">
-            <a:alphaModFix/>
-          </a:blip>
-          <a:srcRect b="0" l="0" r="0" t="0"/>
-          <a:stretch/>
-        </p:blipFill>
-        <p:spPr>
-          <a:xfrm>
-            <a:off x="152400" y="1170125"/>
-            <a:ext cx="5085144" cy="3820976"/>
-          </a:xfrm>
-          <a:prstGeom prst="rect">
-            <a:avLst/>
-          </a:prstGeom>
-          <a:noFill/>
-          <a:ln>
-            <a:noFill/>
-          </a:ln>
-        </p:spPr>
-      </p:pic>
-    </p:spTree>
-  </p:cSld>
-  <p:clrMapOvr>
-    <a:masterClrMapping/>
-  </p:clrMapOvr>
-</p:sld>
-</file>
-
-<file path=ppt/slides/slide8.xml><?xml version="1.0" encoding="utf-8"?>
-<p:sld xmlns:a="http://schemas.openxmlformats.org/drawingml/2006/main" xmlns:r="http://schemas.openxmlformats.org/officeDocument/2006/relationships" xmlns:mc="http://schemas.openxmlformats.org/markup-compatibility/2006" xmlns:mv="urn:schemas-microsoft-com:mac:vml" xmlns:p="http://schemas.openxmlformats.org/presentationml/2006/main" xmlns:c="http://schemas.openxmlformats.org/drawingml/2006/chart" xmlns:dgm="http://schemas.openxmlformats.org/drawingml/2006/diagram" xmlns:o="urn:schemas-microsoft-com:office:office" xmlns:v="urn:schemas-microsoft-com:vml" xmlns:pvml="urn:schemas-microsoft-com:office:powerpoint" xmlns:com="http://schemas.openxmlformats.org/drawingml/2006/compatibility" xmlns:p14="http://schemas.microsoft.com/office/powerpoint/2010/main" xmlns:p15="http://schemas.microsoft.com/office/powerpoint/2012/main" xmlns:ahyp="http://schemas.microsoft.com/office/drawing/2018/hyperlinkcolor">
-  <p:cSld>
-    <p:spTree>
-      <p:nvGrpSpPr>
-        <p:cNvPr id="96" name="Shape 96"/>
-        <p:cNvGrpSpPr/>
-        <p:nvPr/>
-      </p:nvGrpSpPr>
-      <p:grpSpPr>
-        <a:xfrm>
-          <a:off x="0" y="0"/>
-          <a:ext cx="0" cy="0"/>
-          <a:chOff x="0" y="0"/>
-          <a:chExt cx="0" cy="0"/>
-        </a:xfrm>
-      </p:grpSpPr>
-      <p:sp>
-        <p:nvSpPr>
-          <p:cNvPr id="97" name="Google Shape;97;p20"/>
-          <p:cNvSpPr txBox="1"/>
-          <p:nvPr>
-            <p:ph type="title"/>
-          </p:nvPr>
-        </p:nvSpPr>
-        <p:spPr>
-          <a:xfrm>
-            <a:off x="311700" y="445025"/>
-            <a:ext cx="8520600" cy="572700"/>
-          </a:xfrm>
-          <a:prstGeom prst="rect">
-            <a:avLst/>
-          </a:prstGeom>
-          <a:noFill/>
-          <a:ln>
-            <a:noFill/>
-          </a:ln>
-        </p:spPr>
-        <p:txBody>
-          <a:bodyPr anchorCtr="0" anchor="t" bIns="91425" lIns="91425" spcFirstLastPara="1" rIns="91425" wrap="square" tIns="91425">
-            <a:normAutofit fontScale="90000"/>
-          </a:bodyPr>
-          <a:lstStyle/>
-          <a:p>
-            <a:pPr indent="0" lvl="0" marL="0" rtl="0" algn="l">
-              <a:lnSpc>
-                <a:spcPct val="100000"/>
-              </a:lnSpc>
-              <a:spcBef>
-                <a:spcPts val="0"/>
-              </a:spcBef>
-              <a:spcAft>
-                <a:spcPts val="0"/>
-              </a:spcAft>
-              <a:buClr>
-                <a:schemeClr val="dk1"/>
-              </a:buClr>
-              <a:buSzPct val="39285"/>
-              <a:buFont typeface="Arial"/>
-              <a:buNone/>
-            </a:pPr>
-            <a:r>
-              <a:rPr lang="hu"/>
-              <a:t>Ételfutár Weboldalnak a Regisztrálás Rácsszerkezete:</a:t>
-            </a:r>
-            <a:endParaRPr/>
-          </a:p>
-        </p:txBody>
-      </p:sp>
-      <p:pic>
-        <p:nvPicPr>
-          <p:cNvPr id="98" name="Google Shape;98;p20"/>
-          <p:cNvPicPr preferRelativeResize="0"/>
-          <p:nvPr/>
-        </p:nvPicPr>
-        <p:blipFill rotWithShape="1">
-          <a:blip r:embed="rId3">
-            <a:alphaModFix/>
-          </a:blip>
-          <a:srcRect b="0" l="0" r="0" t="0"/>
-          <a:stretch/>
-        </p:blipFill>
-        <p:spPr>
-          <a:xfrm>
-            <a:off x="152400" y="1170125"/>
-            <a:ext cx="5088948" cy="3820975"/>
           </a:xfrm>
           <a:prstGeom prst="rect">
             <a:avLst/>
@@ -12322,16 +12832,12 @@
               <a:spcAft>
                 <a:spcPts val="0"/>
               </a:spcAft>
-              <a:buClr>
-                <a:schemeClr val="dk1"/>
-              </a:buClr>
-              <a:buSzPct val="39285"/>
-              <a:buFont typeface="Arial"/>
+              <a:buSzPct val="111111"/>
               <a:buNone/>
             </a:pPr>
             <a:r>
               <a:rPr lang="hu"/>
-              <a:t>Ételfutár Weboldalnak a Bejelentkezés Rácsszerkezete:</a:t>
+              <a:t>Ételfutár Weboldalnak a Főoldal Rácsszerkezete:</a:t>
             </a:r>
             <a:endParaRPr/>
           </a:p>
@@ -12353,7 +12859,7 @@
         <p:spPr>
           <a:xfrm>
             <a:off x="152400" y="1170125"/>
-            <a:ext cx="5088948" cy="3820975"/>
+            <a:ext cx="5085144" cy="3820976"/>
           </a:xfrm>
           <a:prstGeom prst="rect">
             <a:avLst/>

</xml_diff>